<commit_message>
Update hydrosat technical proposal PPTX
Replace the Hydrosat 'best technical proposal' PowerPoint file (docs/proposal/hydrosat_best_technical_proposal.pptx). This is a binary update to the proposal slides; no other files were modified in this changeset.
</commit_message>
<xml_diff>
--- a/docs/proposal/hydrosat_best_technical_proposal.pptx
+++ b/docs/proposal/hydrosat_best_technical_proposal.pptx
@@ -5,15 +5,15 @@
     <p:sldMasterId id="2147483648" r:id="rId1"/>
   </p:sldMasterIdLst>
   <p:sldIdLst>
-    <p:sldId id="256" r:id="rId7"/>
-    <p:sldId id="257" r:id="rId8"/>
-    <p:sldId id="258" r:id="rId9"/>
-    <p:sldId id="259" r:id="rId10"/>
-    <p:sldId id="260" r:id="rId11"/>
-    <p:sldId id="261" r:id="rId12"/>
-    <p:sldId id="262" r:id="rId13"/>
+    <p:sldId id="256" r:id="rId2"/>
+    <p:sldId id="257" r:id="rId3"/>
+    <p:sldId id="258" r:id="rId4"/>
+    <p:sldId id="259" r:id="rId5"/>
+    <p:sldId id="260" r:id="rId6"/>
+    <p:sldId id="261" r:id="rId7"/>
+    <p:sldId id="262" r:id="rId8"/>
   </p:sldIdLst>
-  <p:sldSz cx="12191695" cy="6858000" type="screen4x3"/>
+  <p:sldSz cx="12192000" cy="6858000"/>
   <p:notesSz cx="6858000" cy="9144000"/>
   <p:defaultTextStyle>
     <a:defPPr>
@@ -110,6 +110,22 @@
       </a:defRPr>
     </a:lvl9pPr>
   </p:defaultTextStyle>
+  <p:extLst>
+    <p:ext uri="{EFAFB233-063F-42B5-8137-9DF3F51BA10A}">
+      <p15:sldGuideLst xmlns:p15="http://schemas.microsoft.com/office/powerpoint/2012/main">
+        <p15:guide id="1" orient="horz" pos="2160">
+          <p15:clr>
+            <a:srgbClr val="A4A3A4"/>
+          </p15:clr>
+        </p15:guide>
+        <p15:guide id="2" pos="2880">
+          <p15:clr>
+            <a:srgbClr val="A4A3A4"/>
+          </p15:clr>
+        </p15:guide>
+      </p15:sldGuideLst>
+    </p:ext>
+  </p:extLst>
 </p:presentation>
 </file>
 
@@ -151,10 +167,9 @@
           <a:lstStyle/>
           <a:p>
             <a:r>
-              <a:rPr lang="en-US" smtClean="0"/>
+              <a:rPr lang="en-US"/>
               <a:t>Click to edit Master title style</a:t>
             </a:r>
-            <a:endParaRPr lang="en-US"/>
           </a:p>
         </p:txBody>
       </p:sp>
@@ -270,10 +285,9 @@
           </a:lstStyle>
           <a:p>
             <a:r>
-              <a:rPr lang="en-US" smtClean="0"/>
+              <a:rPr lang="en-US"/>
               <a:t>Click to edit Master subtitle style</a:t>
             </a:r>
-            <a:endParaRPr lang="en-US"/>
           </a:p>
         </p:txBody>
       </p:sp>
@@ -294,7 +308,7 @@
           <a:p>
             <a:fld id="{5BCAD085-E8A6-8845-BD4E-CB4CCA059FC4}" type="datetimeFigureOut">
               <a:rPr lang="en-US" smtClean="0"/>
-              <a:t>1/27/13</a:t>
+              <a:t>5/15/2026</a:t>
             </a:fld>
             <a:endParaRPr lang="en-US"/>
           </a:p>
@@ -388,10 +402,9 @@
           <a:lstStyle/>
           <a:p>
             <a:r>
-              <a:rPr lang="en-US" smtClean="0"/>
+              <a:rPr lang="en-US"/>
               <a:t>Click to edit Master title style</a:t>
             </a:r>
-            <a:endParaRPr lang="en-US"/>
           </a:p>
         </p:txBody>
       </p:sp>
@@ -412,38 +425,37 @@
           <a:p>
             <a:pPr lvl="0"/>
             <a:r>
-              <a:rPr lang="en-US" smtClean="0"/>
+              <a:rPr lang="en-US"/>
               <a:t>Click to edit Master text styles</a:t>
             </a:r>
           </a:p>
           <a:p>
             <a:pPr lvl="1"/>
             <a:r>
-              <a:rPr lang="en-US" smtClean="0"/>
+              <a:rPr lang="en-US"/>
               <a:t>Second level</a:t>
             </a:r>
           </a:p>
           <a:p>
             <a:pPr lvl="2"/>
             <a:r>
-              <a:rPr lang="en-US" smtClean="0"/>
+              <a:rPr lang="en-US"/>
               <a:t>Third level</a:t>
             </a:r>
           </a:p>
           <a:p>
             <a:pPr lvl="3"/>
             <a:r>
-              <a:rPr lang="en-US" smtClean="0"/>
+              <a:rPr lang="en-US"/>
               <a:t>Fourth level</a:t>
             </a:r>
           </a:p>
           <a:p>
             <a:pPr lvl="4"/>
             <a:r>
-              <a:rPr lang="en-US" smtClean="0"/>
+              <a:rPr lang="en-US"/>
               <a:t>Fifth level</a:t>
             </a:r>
-            <a:endParaRPr lang="en-US"/>
           </a:p>
         </p:txBody>
       </p:sp>
@@ -464,7 +476,7 @@
           <a:p>
             <a:fld id="{5BCAD085-E8A6-8845-BD4E-CB4CCA059FC4}" type="datetimeFigureOut">
               <a:rPr lang="en-US" smtClean="0"/>
-              <a:t>1/27/13</a:t>
+              <a:t>5/15/2026</a:t>
             </a:fld>
             <a:endParaRPr lang="en-US"/>
           </a:p>
@@ -563,10 +575,9 @@
           <a:lstStyle/>
           <a:p>
             <a:r>
-              <a:rPr lang="en-US" smtClean="0"/>
+              <a:rPr lang="en-US"/>
               <a:t>Click to edit Master title style</a:t>
             </a:r>
-            <a:endParaRPr lang="en-US"/>
           </a:p>
         </p:txBody>
       </p:sp>
@@ -592,38 +603,37 @@
           <a:p>
             <a:pPr lvl="0"/>
             <a:r>
-              <a:rPr lang="en-US" smtClean="0"/>
+              <a:rPr lang="en-US"/>
               <a:t>Click to edit Master text styles</a:t>
             </a:r>
           </a:p>
           <a:p>
             <a:pPr lvl="1"/>
             <a:r>
-              <a:rPr lang="en-US" smtClean="0"/>
+              <a:rPr lang="en-US"/>
               <a:t>Second level</a:t>
             </a:r>
           </a:p>
           <a:p>
             <a:pPr lvl="2"/>
             <a:r>
-              <a:rPr lang="en-US" smtClean="0"/>
+              <a:rPr lang="en-US"/>
               <a:t>Third level</a:t>
             </a:r>
           </a:p>
           <a:p>
             <a:pPr lvl="3"/>
             <a:r>
-              <a:rPr lang="en-US" smtClean="0"/>
+              <a:rPr lang="en-US"/>
               <a:t>Fourth level</a:t>
             </a:r>
           </a:p>
           <a:p>
             <a:pPr lvl="4"/>
             <a:r>
-              <a:rPr lang="en-US" smtClean="0"/>
+              <a:rPr lang="en-US"/>
               <a:t>Fifth level</a:t>
             </a:r>
-            <a:endParaRPr lang="en-US"/>
           </a:p>
         </p:txBody>
       </p:sp>
@@ -644,7 +654,7 @@
           <a:p>
             <a:fld id="{5BCAD085-E8A6-8845-BD4E-CB4CCA059FC4}" type="datetimeFigureOut">
               <a:rPr lang="en-US" smtClean="0"/>
-              <a:t>1/27/13</a:t>
+              <a:t>5/15/2026</a:t>
             </a:fld>
             <a:endParaRPr lang="en-US"/>
           </a:p>
@@ -738,10 +748,9 @@
           <a:lstStyle/>
           <a:p>
             <a:r>
-              <a:rPr lang="en-US" smtClean="0"/>
+              <a:rPr lang="en-US"/>
               <a:t>Click to edit Master title style</a:t>
             </a:r>
-            <a:endParaRPr lang="en-US"/>
           </a:p>
         </p:txBody>
       </p:sp>
@@ -762,38 +771,37 @@
           <a:p>
             <a:pPr lvl="0"/>
             <a:r>
-              <a:rPr lang="en-US" smtClean="0"/>
+              <a:rPr lang="en-US"/>
               <a:t>Click to edit Master text styles</a:t>
             </a:r>
           </a:p>
           <a:p>
             <a:pPr lvl="1"/>
             <a:r>
-              <a:rPr lang="en-US" smtClean="0"/>
+              <a:rPr lang="en-US"/>
               <a:t>Second level</a:t>
             </a:r>
           </a:p>
           <a:p>
             <a:pPr lvl="2"/>
             <a:r>
-              <a:rPr lang="en-US" smtClean="0"/>
+              <a:rPr lang="en-US"/>
               <a:t>Third level</a:t>
             </a:r>
           </a:p>
           <a:p>
             <a:pPr lvl="3"/>
             <a:r>
-              <a:rPr lang="en-US" smtClean="0"/>
+              <a:rPr lang="en-US"/>
               <a:t>Fourth level</a:t>
             </a:r>
           </a:p>
           <a:p>
             <a:pPr lvl="4"/>
             <a:r>
-              <a:rPr lang="en-US" smtClean="0"/>
+              <a:rPr lang="en-US"/>
               <a:t>Fifth level</a:t>
             </a:r>
-            <a:endParaRPr lang="en-US"/>
           </a:p>
         </p:txBody>
       </p:sp>
@@ -814,7 +822,7 @@
           <a:p>
             <a:fld id="{5BCAD085-E8A6-8845-BD4E-CB4CCA059FC4}" type="datetimeFigureOut">
               <a:rPr lang="en-US" smtClean="0"/>
-              <a:t>1/27/13</a:t>
+              <a:t>5/15/2026</a:t>
             </a:fld>
             <a:endParaRPr lang="en-US"/>
           </a:p>
@@ -917,10 +925,9 @@
           </a:lstStyle>
           <a:p>
             <a:r>
-              <a:rPr lang="en-US" smtClean="0"/>
+              <a:rPr lang="en-US"/>
               <a:t>Click to edit Master title style</a:t>
             </a:r>
-            <a:endParaRPr lang="en-US"/>
           </a:p>
         </p:txBody>
       </p:sp>
@@ -1037,7 +1044,7 @@
           <a:p>
             <a:pPr lvl="0"/>
             <a:r>
-              <a:rPr lang="en-US" smtClean="0"/>
+              <a:rPr lang="en-US"/>
               <a:t>Click to edit Master text styles</a:t>
             </a:r>
           </a:p>
@@ -1060,7 +1067,7 @@
           <a:p>
             <a:fld id="{5BCAD085-E8A6-8845-BD4E-CB4CCA059FC4}" type="datetimeFigureOut">
               <a:rPr lang="en-US" smtClean="0"/>
-              <a:t>1/27/13</a:t>
+              <a:t>5/15/2026</a:t>
             </a:fld>
             <a:endParaRPr lang="en-US"/>
           </a:p>
@@ -1154,10 +1161,9 @@
           <a:lstStyle/>
           <a:p>
             <a:r>
-              <a:rPr lang="en-US" smtClean="0"/>
+              <a:rPr lang="en-US"/>
               <a:t>Click to edit Master title style</a:t>
             </a:r>
-            <a:endParaRPr lang="en-US"/>
           </a:p>
         </p:txBody>
       </p:sp>
@@ -1211,38 +1217,37 @@
           <a:p>
             <a:pPr lvl="0"/>
             <a:r>
-              <a:rPr lang="en-US" smtClean="0"/>
+              <a:rPr lang="en-US"/>
               <a:t>Click to edit Master text styles</a:t>
             </a:r>
           </a:p>
           <a:p>
             <a:pPr lvl="1"/>
             <a:r>
-              <a:rPr lang="en-US" smtClean="0"/>
+              <a:rPr lang="en-US"/>
               <a:t>Second level</a:t>
             </a:r>
           </a:p>
           <a:p>
             <a:pPr lvl="2"/>
             <a:r>
-              <a:rPr lang="en-US" smtClean="0"/>
+              <a:rPr lang="en-US"/>
               <a:t>Third level</a:t>
             </a:r>
           </a:p>
           <a:p>
             <a:pPr lvl="3"/>
             <a:r>
-              <a:rPr lang="en-US" smtClean="0"/>
+              <a:rPr lang="en-US"/>
               <a:t>Fourth level</a:t>
             </a:r>
           </a:p>
           <a:p>
             <a:pPr lvl="4"/>
             <a:r>
-              <a:rPr lang="en-US" smtClean="0"/>
+              <a:rPr lang="en-US"/>
               <a:t>Fifth level</a:t>
             </a:r>
-            <a:endParaRPr lang="en-US"/>
           </a:p>
         </p:txBody>
       </p:sp>
@@ -1296,38 +1301,37 @@
           <a:p>
             <a:pPr lvl="0"/>
             <a:r>
-              <a:rPr lang="en-US" smtClean="0"/>
+              <a:rPr lang="en-US"/>
               <a:t>Click to edit Master text styles</a:t>
             </a:r>
           </a:p>
           <a:p>
             <a:pPr lvl="1"/>
             <a:r>
-              <a:rPr lang="en-US" smtClean="0"/>
+              <a:rPr lang="en-US"/>
               <a:t>Second level</a:t>
             </a:r>
           </a:p>
           <a:p>
             <a:pPr lvl="2"/>
             <a:r>
-              <a:rPr lang="en-US" smtClean="0"/>
+              <a:rPr lang="en-US"/>
               <a:t>Third level</a:t>
             </a:r>
           </a:p>
           <a:p>
             <a:pPr lvl="3"/>
             <a:r>
-              <a:rPr lang="en-US" smtClean="0"/>
+              <a:rPr lang="en-US"/>
               <a:t>Fourth level</a:t>
             </a:r>
           </a:p>
           <a:p>
             <a:pPr lvl="4"/>
             <a:r>
-              <a:rPr lang="en-US" smtClean="0"/>
+              <a:rPr lang="en-US"/>
               <a:t>Fifth level</a:t>
             </a:r>
-            <a:endParaRPr lang="en-US"/>
           </a:p>
         </p:txBody>
       </p:sp>
@@ -1348,7 +1352,7 @@
           <a:p>
             <a:fld id="{5BCAD085-E8A6-8845-BD4E-CB4CCA059FC4}" type="datetimeFigureOut">
               <a:rPr lang="en-US" smtClean="0"/>
-              <a:t>1/27/13</a:t>
+              <a:t>5/15/2026</a:t>
             </a:fld>
             <a:endParaRPr lang="en-US"/>
           </a:p>
@@ -1446,10 +1450,9 @@
           </a:lstStyle>
           <a:p>
             <a:r>
-              <a:rPr lang="en-US" smtClean="0"/>
+              <a:rPr lang="en-US"/>
               <a:t>Click to edit Master title style</a:t>
             </a:r>
-            <a:endParaRPr lang="en-US"/>
           </a:p>
         </p:txBody>
       </p:sp>
@@ -1512,7 +1515,7 @@
           <a:p>
             <a:pPr lvl="0"/>
             <a:r>
-              <a:rPr lang="en-US" smtClean="0"/>
+              <a:rPr lang="en-US"/>
               <a:t>Click to edit Master text styles</a:t>
             </a:r>
           </a:p>
@@ -1568,38 +1571,37 @@
           <a:p>
             <a:pPr lvl="0"/>
             <a:r>
-              <a:rPr lang="en-US" smtClean="0"/>
+              <a:rPr lang="en-US"/>
               <a:t>Click to edit Master text styles</a:t>
             </a:r>
           </a:p>
           <a:p>
             <a:pPr lvl="1"/>
             <a:r>
-              <a:rPr lang="en-US" smtClean="0"/>
+              <a:rPr lang="en-US"/>
               <a:t>Second level</a:t>
             </a:r>
           </a:p>
           <a:p>
             <a:pPr lvl="2"/>
             <a:r>
-              <a:rPr lang="en-US" smtClean="0"/>
+              <a:rPr lang="en-US"/>
               <a:t>Third level</a:t>
             </a:r>
           </a:p>
           <a:p>
             <a:pPr lvl="3"/>
             <a:r>
-              <a:rPr lang="en-US" smtClean="0"/>
+              <a:rPr lang="en-US"/>
               <a:t>Fourth level</a:t>
             </a:r>
           </a:p>
           <a:p>
             <a:pPr lvl="4"/>
             <a:r>
-              <a:rPr lang="en-US" smtClean="0"/>
+              <a:rPr lang="en-US"/>
               <a:t>Fifth level</a:t>
             </a:r>
-            <a:endParaRPr lang="en-US"/>
           </a:p>
         </p:txBody>
       </p:sp>
@@ -1662,7 +1664,7 @@
           <a:p>
             <a:pPr lvl="0"/>
             <a:r>
-              <a:rPr lang="en-US" smtClean="0"/>
+              <a:rPr lang="en-US"/>
               <a:t>Click to edit Master text styles</a:t>
             </a:r>
           </a:p>
@@ -1718,38 +1720,37 @@
           <a:p>
             <a:pPr lvl="0"/>
             <a:r>
-              <a:rPr lang="en-US" smtClean="0"/>
+              <a:rPr lang="en-US"/>
               <a:t>Click to edit Master text styles</a:t>
             </a:r>
           </a:p>
           <a:p>
             <a:pPr lvl="1"/>
             <a:r>
-              <a:rPr lang="en-US" smtClean="0"/>
+              <a:rPr lang="en-US"/>
               <a:t>Second level</a:t>
             </a:r>
           </a:p>
           <a:p>
             <a:pPr lvl="2"/>
             <a:r>
-              <a:rPr lang="en-US" smtClean="0"/>
+              <a:rPr lang="en-US"/>
               <a:t>Third level</a:t>
             </a:r>
           </a:p>
           <a:p>
             <a:pPr lvl="3"/>
             <a:r>
-              <a:rPr lang="en-US" smtClean="0"/>
+              <a:rPr lang="en-US"/>
               <a:t>Fourth level</a:t>
             </a:r>
           </a:p>
           <a:p>
             <a:pPr lvl="4"/>
             <a:r>
-              <a:rPr lang="en-US" smtClean="0"/>
+              <a:rPr lang="en-US"/>
               <a:t>Fifth level</a:t>
             </a:r>
-            <a:endParaRPr lang="en-US"/>
           </a:p>
         </p:txBody>
       </p:sp>
@@ -1770,7 +1771,7 @@
           <a:p>
             <a:fld id="{5BCAD085-E8A6-8845-BD4E-CB4CCA059FC4}" type="datetimeFigureOut">
               <a:rPr lang="en-US" smtClean="0"/>
-              <a:t>1/27/13</a:t>
+              <a:t>5/15/2026</a:t>
             </a:fld>
             <a:endParaRPr lang="en-US"/>
           </a:p>
@@ -1864,10 +1865,9 @@
           <a:lstStyle/>
           <a:p>
             <a:r>
-              <a:rPr lang="en-US" smtClean="0"/>
+              <a:rPr lang="en-US"/>
               <a:t>Click to edit Master title style</a:t>
             </a:r>
-            <a:endParaRPr lang="en-US"/>
           </a:p>
         </p:txBody>
       </p:sp>
@@ -1888,7 +1888,7 @@
           <a:p>
             <a:fld id="{5BCAD085-E8A6-8845-BD4E-CB4CCA059FC4}" type="datetimeFigureOut">
               <a:rPr lang="en-US" smtClean="0"/>
-              <a:t>1/27/13</a:t>
+              <a:t>5/15/2026</a:t>
             </a:fld>
             <a:endParaRPr lang="en-US"/>
           </a:p>
@@ -1983,7 +1983,7 @@
           <a:p>
             <a:fld id="{5BCAD085-E8A6-8845-BD4E-CB4CCA059FC4}" type="datetimeFigureOut">
               <a:rPr lang="en-US" smtClean="0"/>
-              <a:t>1/27/13</a:t>
+              <a:t>5/15/2026</a:t>
             </a:fld>
             <a:endParaRPr lang="en-US"/>
           </a:p>
@@ -2086,10 +2086,9 @@
           </a:lstStyle>
           <a:p>
             <a:r>
-              <a:rPr lang="en-US" smtClean="0"/>
+              <a:rPr lang="en-US"/>
               <a:t>Click to edit Master title style</a:t>
             </a:r>
-            <a:endParaRPr lang="en-US"/>
           </a:p>
         </p:txBody>
       </p:sp>
@@ -2143,38 +2142,37 @@
           <a:p>
             <a:pPr lvl="0"/>
             <a:r>
-              <a:rPr lang="en-US" smtClean="0"/>
+              <a:rPr lang="en-US"/>
               <a:t>Click to edit Master text styles</a:t>
             </a:r>
           </a:p>
           <a:p>
             <a:pPr lvl="1"/>
             <a:r>
-              <a:rPr lang="en-US" smtClean="0"/>
+              <a:rPr lang="en-US"/>
               <a:t>Second level</a:t>
             </a:r>
           </a:p>
           <a:p>
             <a:pPr lvl="2"/>
             <a:r>
-              <a:rPr lang="en-US" smtClean="0"/>
+              <a:rPr lang="en-US"/>
               <a:t>Third level</a:t>
             </a:r>
           </a:p>
           <a:p>
             <a:pPr lvl="3"/>
             <a:r>
-              <a:rPr lang="en-US" smtClean="0"/>
+              <a:rPr lang="en-US"/>
               <a:t>Fourth level</a:t>
             </a:r>
           </a:p>
           <a:p>
             <a:pPr lvl="4"/>
             <a:r>
-              <a:rPr lang="en-US" smtClean="0"/>
+              <a:rPr lang="en-US"/>
               <a:t>Fifth level</a:t>
             </a:r>
-            <a:endParaRPr lang="en-US"/>
           </a:p>
         </p:txBody>
       </p:sp>
@@ -2237,7 +2235,7 @@
           <a:p>
             <a:pPr lvl="0"/>
             <a:r>
-              <a:rPr lang="en-US" smtClean="0"/>
+              <a:rPr lang="en-US"/>
               <a:t>Click to edit Master text styles</a:t>
             </a:r>
           </a:p>
@@ -2260,7 +2258,7 @@
           <a:p>
             <a:fld id="{5BCAD085-E8A6-8845-BD4E-CB4CCA059FC4}" type="datetimeFigureOut">
               <a:rPr lang="en-US" smtClean="0"/>
-              <a:t>1/27/13</a:t>
+              <a:t>5/15/2026</a:t>
             </a:fld>
             <a:endParaRPr lang="en-US"/>
           </a:p>
@@ -2363,10 +2361,9 @@
           </a:lstStyle>
           <a:p>
             <a:r>
-              <a:rPr lang="en-US" smtClean="0"/>
+              <a:rPr lang="en-US"/>
               <a:t>Click to edit Master title style</a:t>
             </a:r>
-            <a:endParaRPr lang="en-US"/>
           </a:p>
         </p:txBody>
       </p:sp>
@@ -2490,7 +2487,7 @@
           <a:p>
             <a:pPr lvl="0"/>
             <a:r>
-              <a:rPr lang="en-US" smtClean="0"/>
+              <a:rPr lang="en-US"/>
               <a:t>Click to edit Master text styles</a:t>
             </a:r>
           </a:p>
@@ -2513,7 +2510,7 @@
           <a:p>
             <a:fld id="{5BCAD085-E8A6-8845-BD4E-CB4CCA059FC4}" type="datetimeFigureOut">
               <a:rPr lang="en-US" smtClean="0"/>
-              <a:t>1/27/13</a:t>
+              <a:t>5/15/2026</a:t>
             </a:fld>
             <a:endParaRPr lang="en-US"/>
           </a:p>
@@ -2622,10 +2619,9 @@
           <a:lstStyle/>
           <a:p>
             <a:r>
-              <a:rPr lang="en-US" smtClean="0"/>
+              <a:rPr lang="en-US"/>
               <a:t>Click to edit Master title style</a:t>
             </a:r>
-            <a:endParaRPr lang="en-US"/>
           </a:p>
         </p:txBody>
       </p:sp>
@@ -2656,38 +2652,37 @@
           <a:p>
             <a:pPr lvl="0"/>
             <a:r>
-              <a:rPr lang="en-US" smtClean="0"/>
+              <a:rPr lang="en-US"/>
               <a:t>Click to edit Master text styles</a:t>
             </a:r>
           </a:p>
           <a:p>
             <a:pPr lvl="1"/>
             <a:r>
-              <a:rPr lang="en-US" smtClean="0"/>
+              <a:rPr lang="en-US"/>
               <a:t>Second level</a:t>
             </a:r>
           </a:p>
           <a:p>
             <a:pPr lvl="2"/>
             <a:r>
-              <a:rPr lang="en-US" smtClean="0"/>
+              <a:rPr lang="en-US"/>
               <a:t>Third level</a:t>
             </a:r>
           </a:p>
           <a:p>
             <a:pPr lvl="3"/>
             <a:r>
-              <a:rPr lang="en-US" smtClean="0"/>
+              <a:rPr lang="en-US"/>
               <a:t>Fourth level</a:t>
             </a:r>
           </a:p>
           <a:p>
             <a:pPr lvl="4"/>
             <a:r>
-              <a:rPr lang="en-US" smtClean="0"/>
+              <a:rPr lang="en-US"/>
               <a:t>Fifth level</a:t>
             </a:r>
-            <a:endParaRPr lang="en-US"/>
           </a:p>
         </p:txBody>
       </p:sp>
@@ -2726,7 +2721,7 @@
           <a:p>
             <a:fld id="{5BCAD085-E8A6-8845-BD4E-CB4CCA059FC4}" type="datetimeFigureOut">
               <a:rPr lang="en-US" smtClean="0"/>
-              <a:t>1/27/13</a:t>
+              <a:t>5/15/2026</a:t>
             </a:fld>
             <a:endParaRPr lang="en-US"/>
           </a:p>
@@ -3085,7 +3080,7 @@
 </file>
 
 <file path=ppt/slides/slide1.xml><?xml version="1.0" encoding="utf-8"?>
-<p:sld xmlns:a="http://schemas.openxmlformats.org/drawingml/2006/main" xmlns:p="http://schemas.openxmlformats.org/presentationml/2006/main" xmlns:r="http://schemas.openxmlformats.org/officeDocument/2006/relationships">
+<p:sld xmlns:a="http://schemas.openxmlformats.org/drawingml/2006/main" xmlns:r="http://schemas.openxmlformats.org/officeDocument/2006/relationships" xmlns:p="http://schemas.openxmlformats.org/presentationml/2006/main">
   <p:cSld>
     <p:bg>
       <p:bgPr>
@@ -3101,7 +3096,14 @@
         <p:cNvGrpSpPr/>
         <p:nvPr/>
       </p:nvGrpSpPr>
-      <p:grpSpPr/>
+      <p:grpSpPr>
+        <a:xfrm>
+          <a:off x="0" y="0"/>
+          <a:ext cx="0" cy="0"/>
+          <a:chOff x="0" y="0"/>
+          <a:chExt cx="0" cy="0"/>
+        </a:xfrm>
+      </p:grpSpPr>
       <p:sp>
         <p:nvSpPr>
           <p:cNvPr id="2" name="Rounded Rectangle 1"/>
@@ -3164,7 +3166,7 @@
         </p:nvSpPr>
         <p:spPr>
           <a:xfrm>
-            <a:off x="8732520" y="777240"/>
+            <a:off x="1188720" y="2537459"/>
             <a:ext cx="1371600" cy="1371600"/>
           </a:xfrm>
           <a:prstGeom prst="ellipse">
@@ -3196,6 +3198,7 @@
           <a:lstStyle/>
           <a:p>
             <a:pPr algn="ctr"/>
+            <a:endParaRPr/>
           </a:p>
         </p:txBody>
       </p:sp>
@@ -3207,7 +3210,7 @@
         </p:nvSpPr>
         <p:spPr>
           <a:xfrm>
-            <a:off x="9189720" y="1234440"/>
+            <a:off x="5532120" y="3108960"/>
             <a:ext cx="914400" cy="914400"/>
           </a:xfrm>
           <a:prstGeom prst="ellipse">
@@ -3239,6 +3242,7 @@
           <a:lstStyle/>
           <a:p>
             <a:pPr algn="ctr"/>
+            <a:endParaRPr/>
           </a:p>
         </p:txBody>
       </p:sp>
@@ -3250,7 +3254,7 @@
         </p:nvSpPr>
         <p:spPr>
           <a:xfrm>
-            <a:off x="10058400" y="685800"/>
+            <a:off x="3779521" y="4069080"/>
             <a:ext cx="658368" cy="658368"/>
           </a:xfrm>
           <a:prstGeom prst="ellipse">
@@ -3282,6 +3286,7 @@
           <a:lstStyle/>
           <a:p>
             <a:pPr algn="ctr"/>
+            <a:endParaRPr/>
           </a:p>
         </p:txBody>
       </p:sp>
@@ -3293,8 +3298,8 @@
         </p:nvSpPr>
         <p:spPr>
           <a:xfrm>
-            <a:off x="658368" y="1005840"/>
-            <a:ext cx="7223760" cy="1645920"/>
+            <a:off x="397764" y="791173"/>
+            <a:ext cx="7941564" cy="1215717"/>
           </a:xfrm>
           <a:prstGeom prst="rect">
             <a:avLst/>
@@ -3313,13 +3318,22 @@
               </a:spcAft>
             </a:pPr>
             <a:r>
-              <a:rPr sz="2600" b="1">
+              <a:rPr sz="2800" b="1" dirty="0" err="1">
                 <a:solidFill>
                   <a:srgbClr val="F4F8FF"/>
                 </a:solidFill>
                 <a:latin typeface="Aptos"/>
               </a:rPr>
-              <a:t>HydroSat On-Orbit Water Quality Inference</a:t>
+              <a:t>HydroSat</a:t>
+            </a:r>
+            <a:r>
+              <a:rPr sz="2800" b="1" dirty="0">
+                <a:solidFill>
+                  <a:srgbClr val="F4F8FF"/>
+                </a:solidFill>
+                <a:latin typeface="Aptos"/>
+              </a:rPr>
+              <a:t> On-Orbit Water Quality Inference</a:t>
             </a:r>
           </a:p>
           <a:p>
@@ -3329,7 +3343,7 @@
               </a:spcAft>
             </a:pPr>
             <a:r>
-              <a:rPr sz="1500" b="1">
+              <a:rPr sz="1600" b="1" dirty="0">
                 <a:solidFill>
                   <a:srgbClr val="20C9DA"/>
                 </a:solidFill>
@@ -3345,7 +3359,7 @@
               </a:spcAft>
             </a:pPr>
             <a:r>
-              <a:rPr sz="1100" b="0">
+              <a:rPr sz="1200" b="0" dirty="0">
                 <a:solidFill>
                   <a:srgbClr val="B7C2D7"/>
                 </a:solidFill>
@@ -3364,7 +3378,7 @@
         </p:nvSpPr>
         <p:spPr>
           <a:xfrm>
-            <a:off x="7818120" y="1078992"/>
+            <a:off x="8083296" y="1645920"/>
             <a:ext cx="3703320" cy="4526280"/>
           </a:xfrm>
           <a:prstGeom prst="roundRect">
@@ -3398,6 +3412,7 @@
           <a:lstStyle/>
           <a:p>
             <a:pPr algn="ctr"/>
+            <a:endParaRPr/>
           </a:p>
         </p:txBody>
       </p:sp>
@@ -3409,8 +3424,8 @@
         </p:nvSpPr>
         <p:spPr>
           <a:xfrm>
-            <a:off x="8046720" y="1298448"/>
-            <a:ext cx="3200400" cy="4023360"/>
+            <a:off x="8339328" y="1858498"/>
+            <a:ext cx="3200400" cy="4101123"/>
           </a:xfrm>
           <a:prstGeom prst="rect">
             <a:avLst/>
@@ -3429,7 +3444,7 @@
               </a:spcAft>
             </a:pPr>
             <a:r>
-              <a:rPr sz="1400" b="1">
+              <a:rPr b="1" dirty="0">
                 <a:solidFill>
                   <a:srgbClr val="F5B335"/>
                 </a:solidFill>
@@ -3445,7 +3460,7 @@
               </a:spcAft>
             </a:pPr>
             <a:r>
-              <a:rPr sz="1100" b="1">
+              <a:rPr sz="1400" b="1" dirty="0">
                 <a:solidFill>
                   <a:srgbClr val="F4F8FF"/>
                 </a:solidFill>
@@ -3461,7 +3476,7 @@
               </a:spcAft>
             </a:pPr>
             <a:r>
-              <a:rPr sz="1000" b="0">
+              <a:rPr sz="1100" b="0" dirty="0">
                 <a:solidFill>
                   <a:srgbClr val="B7C2D7"/>
                 </a:solidFill>
@@ -3477,7 +3492,7 @@
               </a:spcAft>
             </a:pPr>
             <a:r>
-              <a:rPr sz="1100" b="1">
+              <a:rPr sz="1400" b="1" dirty="0">
                 <a:solidFill>
                   <a:srgbClr val="F4F8FF"/>
                 </a:solidFill>
@@ -3493,7 +3508,7 @@
               </a:spcAft>
             </a:pPr>
             <a:r>
-              <a:rPr sz="2800" b="1">
+              <a:rPr sz="3600" b="1" dirty="0">
                 <a:solidFill>
                   <a:srgbClr val="F4F8FF"/>
                 </a:solidFill>
@@ -3509,7 +3524,7 @@
               </a:spcAft>
             </a:pPr>
             <a:r>
-              <a:rPr sz="900" b="0">
+              <a:rPr sz="1050" b="0" dirty="0">
                 <a:solidFill>
                   <a:srgbClr val="B7C2D7"/>
                 </a:solidFill>
@@ -3525,7 +3540,7 @@
               </a:spcAft>
             </a:pPr>
             <a:r>
-              <a:rPr sz="1100" b="1">
+              <a:rPr sz="1400" b="1" dirty="0">
                 <a:solidFill>
                   <a:srgbClr val="F4F8FF"/>
                 </a:solidFill>
@@ -3541,7 +3556,7 @@
               </a:spcAft>
             </a:pPr>
             <a:r>
-              <a:rPr sz="2000" b="1">
+              <a:rPr sz="2800" b="1" dirty="0">
                 <a:solidFill>
                   <a:srgbClr val="F4F8FF"/>
                 </a:solidFill>
@@ -3557,7 +3572,7 @@
               </a:spcAft>
             </a:pPr>
             <a:r>
-              <a:rPr sz="900" b="0">
+              <a:rPr sz="1050" b="0" dirty="0">
                 <a:solidFill>
                   <a:srgbClr val="B7C2D7"/>
                 </a:solidFill>
@@ -3573,7 +3588,7 @@
               </a:spcAft>
             </a:pPr>
             <a:r>
-              <a:rPr sz="1100" b="1">
+              <a:rPr sz="1400" b="1" dirty="0">
                 <a:solidFill>
                   <a:srgbClr val="F4F8FF"/>
                 </a:solidFill>
@@ -3589,13 +3604,22 @@
               </a:spcAft>
             </a:pPr>
             <a:r>
-              <a:rPr sz="1000" b="0">
+              <a:rPr sz="1100" b="0" dirty="0" err="1">
                 <a:solidFill>
                   <a:srgbClr val="B7C2D7"/>
                 </a:solidFill>
                 <a:latin typeface="Aptos"/>
               </a:rPr>
-              <a:t>Dockerized /input -&gt; /output runtime, no external code downloads, container-ready for GitLab submission.</a:t>
+              <a:t>Dockerized</a:t>
+            </a:r>
+            <a:r>
+              <a:rPr sz="1100" b="0" dirty="0">
+                <a:solidFill>
+                  <a:srgbClr val="B7C2D7"/>
+                </a:solidFill>
+                <a:latin typeface="Aptos"/>
+              </a:rPr>
+              <a:t> /input -&gt; /output runtime, no external code downloads, container-ready for GitLab submission.</a:t>
             </a:r>
           </a:p>
         </p:txBody>
@@ -3608,8 +3632,8 @@
         </p:nvSpPr>
         <p:spPr>
           <a:xfrm>
-            <a:off x="676656" y="5303520"/>
-            <a:ext cx="6949440" cy="914400"/>
+            <a:off x="652272" y="5422392"/>
+            <a:ext cx="6949440" cy="754053"/>
           </a:xfrm>
           <a:prstGeom prst="rect">
             <a:avLst/>
@@ -3628,13 +3652,31 @@
               </a:spcAft>
             </a:pPr>
             <a:r>
-              <a:rPr sz="1200" b="1">
+              <a:rPr sz="1400" b="1" dirty="0">
                 <a:solidFill>
                   <a:srgbClr val="F4F8FF"/>
                 </a:solidFill>
                 <a:latin typeface="Aptos"/>
               </a:rPr>
-              <a:t>Team: HydroSat Systems</a:t>
+              <a:t>Team: </a:t>
+            </a:r>
+            <a:r>
+              <a:rPr sz="1400" b="1" dirty="0" err="1">
+                <a:solidFill>
+                  <a:srgbClr val="F4F8FF"/>
+                </a:solidFill>
+                <a:latin typeface="Aptos"/>
+              </a:rPr>
+              <a:t>HydroSat</a:t>
+            </a:r>
+            <a:r>
+              <a:rPr sz="1400" b="1" dirty="0">
+                <a:solidFill>
+                  <a:srgbClr val="F4F8FF"/>
+                </a:solidFill>
+                <a:latin typeface="Aptos"/>
+              </a:rPr>
+              <a:t> Systems</a:t>
             </a:r>
           </a:p>
           <a:p>
@@ -3644,7 +3686,7 @@
               </a:spcAft>
             </a:pPr>
             <a:r>
-              <a:rPr sz="1100" b="0">
+              <a:rPr sz="1200" b="0" dirty="0">
                 <a:solidFill>
                   <a:srgbClr val="B7C2D7"/>
                 </a:solidFill>
@@ -3660,7 +3702,7 @@
               </a:spcAft>
             </a:pPr>
             <a:r>
-              <a:rPr sz="1100" b="0">
+              <a:rPr sz="1200" b="0" dirty="0">
                 <a:solidFill>
                   <a:srgbClr val="B7C2D7"/>
                 </a:solidFill>
@@ -3715,7 +3757,7 @@
 </file>
 
 <file path=ppt/slides/slide2.xml><?xml version="1.0" encoding="utf-8"?>
-<p:sld xmlns:a="http://schemas.openxmlformats.org/drawingml/2006/main" xmlns:p="http://schemas.openxmlformats.org/presentationml/2006/main" xmlns:r="http://schemas.openxmlformats.org/officeDocument/2006/relationships">
+<p:sld xmlns:a="http://schemas.openxmlformats.org/drawingml/2006/main" xmlns:r="http://schemas.openxmlformats.org/officeDocument/2006/relationships" xmlns:p="http://schemas.openxmlformats.org/presentationml/2006/main">
   <p:cSld>
     <p:bg>
       <p:bgPr>
@@ -3731,7 +3773,14 @@
         <p:cNvGrpSpPr/>
         <p:nvPr/>
       </p:nvGrpSpPr>
-      <p:grpSpPr/>
+      <p:grpSpPr>
+        <a:xfrm>
+          <a:off x="0" y="0"/>
+          <a:ext cx="0" cy="0"/>
+          <a:chOff x="0" y="0"/>
+          <a:chExt cx="0" cy="0"/>
+        </a:xfrm>
+      </p:grpSpPr>
       <p:sp>
         <p:nvSpPr>
           <p:cNvPr id="2" name="Rounded Rectangle 1"/>
@@ -3896,6 +3945,7 @@
           <a:lstStyle/>
           <a:p>
             <a:pPr algn="ctr"/>
+            <a:endParaRPr/>
           </a:p>
         </p:txBody>
       </p:sp>
@@ -3908,7 +3958,7 @@
         <p:spPr>
           <a:xfrm>
             <a:off x="658368" y="2121408"/>
-            <a:ext cx="1444752" cy="1133856"/>
+            <a:ext cx="1444752" cy="746358"/>
           </a:xfrm>
           <a:prstGeom prst="rect">
             <a:avLst/>
@@ -3927,7 +3977,7 @@
               </a:spcAft>
             </a:pPr>
             <a:r>
-              <a:rPr sz="1200" b="1">
+              <a:rPr b="1" dirty="0">
                 <a:solidFill>
                   <a:srgbClr val="F5B335"/>
                 </a:solidFill>
@@ -3943,7 +3993,7 @@
               </a:spcAft>
             </a:pPr>
             <a:r>
-              <a:rPr sz="900" b="0">
+              <a:rPr sz="1100" b="0" dirty="0">
                 <a:solidFill>
                   <a:srgbClr val="F4F8FF"/>
                 </a:solidFill>
@@ -3996,6 +4046,7 @@
           <a:lstStyle/>
           <a:p>
             <a:pPr algn="ctr"/>
+            <a:endParaRPr/>
           </a:p>
         </p:txBody>
       </p:sp>
@@ -4041,6 +4092,7 @@
           <a:lstStyle/>
           <a:p>
             <a:pPr algn="ctr"/>
+            <a:endParaRPr/>
           </a:p>
         </p:txBody>
       </p:sp>
@@ -4053,7 +4105,7 @@
         <p:spPr>
           <a:xfrm>
             <a:off x="2542032" y="2121408"/>
-            <a:ext cx="1444752" cy="1133856"/>
+            <a:ext cx="1444752" cy="746358"/>
           </a:xfrm>
           <a:prstGeom prst="rect">
             <a:avLst/>
@@ -4072,7 +4124,7 @@
               </a:spcAft>
             </a:pPr>
             <a:r>
-              <a:rPr sz="1200" b="1">
+              <a:rPr b="1">
                 <a:solidFill>
                   <a:srgbClr val="F5B335"/>
                 </a:solidFill>
@@ -4088,7 +4140,7 @@
               </a:spcAft>
             </a:pPr>
             <a:r>
-              <a:rPr sz="900" b="0">
+              <a:rPr sz="1100" b="0">
                 <a:solidFill>
                   <a:srgbClr val="F4F8FF"/>
                 </a:solidFill>
@@ -4141,6 +4193,7 @@
           <a:lstStyle/>
           <a:p>
             <a:pPr algn="ctr"/>
+            <a:endParaRPr/>
           </a:p>
         </p:txBody>
       </p:sp>
@@ -4186,6 +4239,7 @@
           <a:lstStyle/>
           <a:p>
             <a:pPr algn="ctr"/>
+            <a:endParaRPr/>
           </a:p>
         </p:txBody>
       </p:sp>
@@ -4198,7 +4252,7 @@
         <p:spPr>
           <a:xfrm>
             <a:off x="4425696" y="2121408"/>
-            <a:ext cx="1444752" cy="1133856"/>
+            <a:ext cx="1444752" cy="1084912"/>
           </a:xfrm>
           <a:prstGeom prst="rect">
             <a:avLst/>
@@ -4217,7 +4271,7 @@
               </a:spcAft>
             </a:pPr>
             <a:r>
-              <a:rPr sz="1200" b="1">
+              <a:rPr b="1">
                 <a:solidFill>
                   <a:srgbClr val="F5B335"/>
                 </a:solidFill>
@@ -4233,7 +4287,7 @@
               </a:spcAft>
             </a:pPr>
             <a:r>
-              <a:rPr sz="900" b="0">
+              <a:rPr sz="1100" b="0">
                 <a:solidFill>
                   <a:srgbClr val="F4F8FF"/>
                 </a:solidFill>
@@ -4286,6 +4340,7 @@
           <a:lstStyle/>
           <a:p>
             <a:pPr algn="ctr"/>
+            <a:endParaRPr/>
           </a:p>
         </p:txBody>
       </p:sp>
@@ -4331,6 +4386,7 @@
           <a:lstStyle/>
           <a:p>
             <a:pPr algn="ctr"/>
+            <a:endParaRPr/>
           </a:p>
         </p:txBody>
       </p:sp>
@@ -4343,7 +4399,7 @@
         <p:spPr>
           <a:xfrm>
             <a:off x="6309360" y="2121408"/>
-            <a:ext cx="1444752" cy="1133856"/>
+            <a:ext cx="1444752" cy="915635"/>
           </a:xfrm>
           <a:prstGeom prst="rect">
             <a:avLst/>
@@ -4362,7 +4418,7 @@
               </a:spcAft>
             </a:pPr>
             <a:r>
-              <a:rPr sz="1200" b="1">
+              <a:rPr b="1">
                 <a:solidFill>
                   <a:srgbClr val="F5B335"/>
                 </a:solidFill>
@@ -4378,7 +4434,7 @@
               </a:spcAft>
             </a:pPr>
             <a:r>
-              <a:rPr sz="900" b="0">
+              <a:rPr sz="1100" b="0">
                 <a:solidFill>
                   <a:srgbClr val="F4F8FF"/>
                 </a:solidFill>
@@ -4431,6 +4487,7 @@
           <a:lstStyle/>
           <a:p>
             <a:pPr algn="ctr"/>
+            <a:endParaRPr/>
           </a:p>
         </p:txBody>
       </p:sp>
@@ -4476,6 +4533,7 @@
           <a:lstStyle/>
           <a:p>
             <a:pPr algn="ctr"/>
+            <a:endParaRPr/>
           </a:p>
         </p:txBody>
       </p:sp>
@@ -4488,7 +4546,7 @@
         <p:spPr>
           <a:xfrm>
             <a:off x="8193023" y="2121408"/>
-            <a:ext cx="1444752" cy="1133856"/>
+            <a:ext cx="1444752" cy="915635"/>
           </a:xfrm>
           <a:prstGeom prst="rect">
             <a:avLst/>
@@ -4507,7 +4565,7 @@
               </a:spcAft>
             </a:pPr>
             <a:r>
-              <a:rPr sz="1200" b="1">
+              <a:rPr b="1">
                 <a:solidFill>
                   <a:srgbClr val="F5B335"/>
                 </a:solidFill>
@@ -4523,7 +4581,7 @@
               </a:spcAft>
             </a:pPr>
             <a:r>
-              <a:rPr sz="900" b="0">
+              <a:rPr sz="1100" b="0">
                 <a:solidFill>
                   <a:srgbClr val="F4F8FF"/>
                 </a:solidFill>
@@ -4576,6 +4634,7 @@
           <a:lstStyle/>
           <a:p>
             <a:pPr algn="ctr"/>
+            <a:endParaRPr/>
           </a:p>
         </p:txBody>
       </p:sp>
@@ -4621,6 +4680,7 @@
           <a:lstStyle/>
           <a:p>
             <a:pPr algn="ctr"/>
+            <a:endParaRPr/>
           </a:p>
         </p:txBody>
       </p:sp>
@@ -4633,7 +4693,7 @@
         <p:spPr>
           <a:xfrm>
             <a:off x="10076688" y="2121408"/>
-            <a:ext cx="1444752" cy="1133856"/>
+            <a:ext cx="1444752" cy="746358"/>
           </a:xfrm>
           <a:prstGeom prst="rect">
             <a:avLst/>
@@ -4652,7 +4712,7 @@
               </a:spcAft>
             </a:pPr>
             <a:r>
-              <a:rPr sz="1200" b="1">
+              <a:rPr b="1">
                 <a:solidFill>
                   <a:srgbClr val="F5B335"/>
                 </a:solidFill>
@@ -4668,7 +4728,7 @@
               </a:spcAft>
             </a:pPr>
             <a:r>
-              <a:rPr sz="900" b="0">
+              <a:rPr sz="1100" b="0">
                 <a:solidFill>
                   <a:srgbClr val="F4F8FF"/>
                 </a:solidFill>
@@ -4721,6 +4781,7 @@
           <a:lstStyle/>
           <a:p>
             <a:pPr algn="ctr"/>
+            <a:endParaRPr/>
           </a:p>
         </p:txBody>
       </p:sp>
@@ -4733,7 +4794,7 @@
         <p:spPr>
           <a:xfrm>
             <a:off x="822960" y="4178808"/>
-            <a:ext cx="4974336" cy="320040"/>
+            <a:ext cx="4974336" cy="307777"/>
           </a:xfrm>
           <a:prstGeom prst="rect">
             <a:avLst/>
@@ -4752,7 +4813,7 @@
               </a:spcAft>
             </a:pPr>
             <a:r>
-              <a:rPr sz="1300" b="1">
+              <a:rPr sz="1400" b="1">
                 <a:solidFill>
                   <a:srgbClr val="F5B335"/>
                 </a:solidFill>
@@ -4772,7 +4833,7 @@
         <p:spPr>
           <a:xfrm>
             <a:off x="859536" y="4507992"/>
-            <a:ext cx="5010912" cy="1280160"/>
+            <a:ext cx="5010912" cy="1023357"/>
           </a:xfrm>
           <a:prstGeom prst="rect">
             <a:avLst/>
@@ -4785,10 +4846,12 @@
           </a:bodyPr>
           <a:lstStyle/>
           <a:p>
-            <a:pPr>
+            <a:pPr marL="171450" indent="-171450">
               <a:spcAft>
                 <a:spcPts val="500"/>
               </a:spcAft>
+              <a:buFont typeface="Arial" panose="020B0604020202020204" pitchFamily="34" charset="0"/>
+              <a:buChar char="•"/>
               <a:defRPr sz="1100">
                 <a:solidFill>
                   <a:srgbClr val="F4F8FF"/>
@@ -4797,14 +4860,17 @@
               </a:defRPr>
             </a:pPr>
             <a:r>
+              <a:rPr sz="1200" dirty="0"/>
               <a:t>paths.py resolves training and inference imagery</a:t>
             </a:r>
           </a:p>
           <a:p>
-            <a:pPr>
+            <a:pPr marL="171450" indent="-171450">
               <a:spcAft>
                 <a:spcPts val="500"/>
               </a:spcAft>
+              <a:buFont typeface="Arial" panose="020B0604020202020204" pitchFamily="34" charset="0"/>
+              <a:buChar char="•"/>
               <a:defRPr sz="1100">
                 <a:solidFill>
                   <a:srgbClr val="F4F8FF"/>
@@ -4813,14 +4879,17 @@
               </a:defRPr>
             </a:pPr>
             <a:r>
+              <a:rPr sz="1200" dirty="0"/>
               <a:t>raster.py converts Lon/Lat to pixels and reads boundless patches</a:t>
             </a:r>
           </a:p>
           <a:p>
-            <a:pPr>
+            <a:pPr marL="171450" indent="-171450">
               <a:spcAft>
                 <a:spcPts val="500"/>
               </a:spcAft>
+              <a:buFont typeface="Arial" panose="020B0604020202020204" pitchFamily="34" charset="0"/>
+              <a:buChar char="•"/>
               <a:defRPr sz="1100">
                 <a:solidFill>
                   <a:srgbClr val="F4F8FF"/>
@@ -4829,14 +4898,17 @@
               </a:defRPr>
             </a:pPr>
             <a:r>
+              <a:rPr sz="1200" dirty="0"/>
               <a:t>features.py computes handcrafted spectral-spatial descriptors</a:t>
             </a:r>
           </a:p>
           <a:p>
-            <a:pPr>
+            <a:pPr marL="171450" indent="-171450">
               <a:spcAft>
                 <a:spcPts val="500"/>
               </a:spcAft>
+              <a:buFont typeface="Arial" panose="020B0604020202020204" pitchFamily="34" charset="0"/>
+              <a:buChar char="•"/>
               <a:defRPr sz="1100">
                 <a:solidFill>
                   <a:srgbClr val="F4F8FF"/>
@@ -4845,6 +4917,7 @@
               </a:defRPr>
             </a:pPr>
             <a:r>
+              <a:rPr sz="1200" dirty="0"/>
               <a:t>infer.py loads models, predicts, calibrates, and writes final JSON</a:t>
             </a:r>
           </a:p>
@@ -4892,6 +4965,7 @@
           <a:lstStyle/>
           <a:p>
             <a:pPr algn="ctr"/>
+            <a:endParaRPr/>
           </a:p>
         </p:txBody>
       </p:sp>
@@ -4904,7 +4978,7 @@
         <p:spPr>
           <a:xfrm>
             <a:off x="6364224" y="4178808"/>
-            <a:ext cx="4974336" cy="320040"/>
+            <a:ext cx="4974336" cy="307777"/>
           </a:xfrm>
           <a:prstGeom prst="rect">
             <a:avLst/>
@@ -4923,7 +4997,7 @@
               </a:spcAft>
             </a:pPr>
             <a:r>
-              <a:rPr sz="1300" b="1">
+              <a:rPr sz="1400" b="1">
                 <a:solidFill>
                   <a:srgbClr val="F5B335"/>
                 </a:solidFill>
@@ -4943,7 +5017,7 @@
         <p:spPr>
           <a:xfrm>
             <a:off x="6400800" y="4507992"/>
-            <a:ext cx="5010912" cy="1280160"/>
+            <a:ext cx="5010912" cy="1023357"/>
           </a:xfrm>
           <a:prstGeom prst="rect">
             <a:avLst/>
@@ -4956,10 +5030,12 @@
           </a:bodyPr>
           <a:lstStyle/>
           <a:p>
-            <a:pPr>
+            <a:pPr marL="171450" indent="-171450">
               <a:spcAft>
                 <a:spcPts val="500"/>
               </a:spcAft>
+              <a:buFont typeface="Arial" panose="020B0604020202020204" pitchFamily="34" charset="0"/>
+              <a:buChar char="•"/>
               <a:defRPr sz="1100">
                 <a:solidFill>
                   <a:srgbClr val="F4F8FF"/>
@@ -4968,14 +5044,17 @@
               </a:defRPr>
             </a:pPr>
             <a:r>
+              <a:rPr sz="1200" dirty="0"/>
               <a:t>Inference-only container workflow with deterministic I/O</a:t>
             </a:r>
           </a:p>
           <a:p>
-            <a:pPr>
+            <a:pPr marL="171450" indent="-171450">
               <a:spcAft>
                 <a:spcPts val="500"/>
               </a:spcAft>
+              <a:buFont typeface="Arial" panose="020B0604020202020204" pitchFamily="34" charset="0"/>
+              <a:buChar char="•"/>
               <a:defRPr sz="1100">
                 <a:solidFill>
                   <a:srgbClr val="F4F8FF"/>
@@ -4984,14 +5063,17 @@
               </a:defRPr>
             </a:pPr>
             <a:r>
+              <a:rPr sz="1200" dirty="0"/>
               <a:t>No training dependency on the competition platform</a:t>
             </a:r>
           </a:p>
           <a:p>
-            <a:pPr>
+            <a:pPr marL="171450" indent="-171450">
               <a:spcAft>
                 <a:spcPts val="500"/>
               </a:spcAft>
+              <a:buFont typeface="Arial" panose="020B0604020202020204" pitchFamily="34" charset="0"/>
+              <a:buChar char="•"/>
               <a:defRPr sz="1100">
                 <a:solidFill>
                   <a:srgbClr val="F4F8FF"/>
@@ -5000,14 +5082,17 @@
               </a:defRPr>
             </a:pPr>
             <a:r>
+              <a:rPr sz="1200" dirty="0"/>
               <a:t>Small default runtime path without mandatory GPU use</a:t>
             </a:r>
           </a:p>
           <a:p>
-            <a:pPr>
+            <a:pPr marL="171450" indent="-171450">
               <a:spcAft>
                 <a:spcPts val="500"/>
               </a:spcAft>
+              <a:buFont typeface="Arial" panose="020B0604020202020204" pitchFamily="34" charset="0"/>
+              <a:buChar char="•"/>
               <a:defRPr sz="1100">
                 <a:solidFill>
                   <a:srgbClr val="F4F8FF"/>
@@ -5016,6 +5101,7 @@
               </a:defRPr>
             </a:pPr>
             <a:r>
+              <a:rPr sz="1200" dirty="0"/>
               <a:t>Easy to audit and refine as better models become available</a:t>
             </a:r>
           </a:p>
@@ -5065,7 +5151,7 @@
 </file>
 
 <file path=ppt/slides/slide3.xml><?xml version="1.0" encoding="utf-8"?>
-<p:sld xmlns:a="http://schemas.openxmlformats.org/drawingml/2006/main" xmlns:p="http://schemas.openxmlformats.org/presentationml/2006/main" xmlns:r="http://schemas.openxmlformats.org/officeDocument/2006/relationships">
+<p:sld xmlns:a="http://schemas.openxmlformats.org/drawingml/2006/main" xmlns:r="http://schemas.openxmlformats.org/officeDocument/2006/relationships" xmlns:p="http://schemas.openxmlformats.org/presentationml/2006/main">
   <p:cSld>
     <p:bg>
       <p:bgPr>
@@ -5081,7 +5167,14 @@
         <p:cNvGrpSpPr/>
         <p:nvPr/>
       </p:nvGrpSpPr>
-      <p:grpSpPr/>
+      <p:grpSpPr>
+        <a:xfrm>
+          <a:off x="0" y="0"/>
+          <a:ext cx="0" cy="0"/>
+          <a:chOff x="0" y="0"/>
+          <a:chExt cx="0" cy="0"/>
+        </a:xfrm>
+      </p:grpSpPr>
       <p:sp>
         <p:nvSpPr>
           <p:cNvPr id="2" name="Rounded Rectangle 1"/>
@@ -5145,7 +5238,7 @@
         <p:spPr>
           <a:xfrm>
             <a:off x="548640" y="749808"/>
-            <a:ext cx="7589520" cy="822960"/>
+            <a:ext cx="9623084" cy="584775"/>
           </a:xfrm>
           <a:prstGeom prst="rect">
             <a:avLst/>
@@ -5159,7 +5252,7 @@
           <a:lstStyle/>
           <a:p>
             <a:r>
-              <a:rPr sz="2500" b="1">
+              <a:rPr sz="3200" b="1">
                 <a:solidFill>
                   <a:srgbClr val="F4F8FF"/>
                 </a:solidFill>
@@ -5178,8 +5271,8 @@
         </p:nvSpPr>
         <p:spPr>
           <a:xfrm>
-            <a:off x="566928" y="1444752"/>
-            <a:ext cx="8046720" cy="438912"/>
+            <a:off x="621792" y="1241689"/>
+            <a:ext cx="6536982" cy="307777"/>
           </a:xfrm>
           <a:prstGeom prst="rect">
             <a:avLst/>
@@ -5193,7 +5286,7 @@
           <a:lstStyle/>
           <a:p>
             <a:r>
-              <a:rPr sz="1150">
+              <a:rPr sz="1400" dirty="0">
                 <a:solidFill>
                   <a:srgbClr val="B7C2D7"/>
                 </a:solidFill>
@@ -5246,6 +5339,7 @@
           <a:lstStyle/>
           <a:p>
             <a:pPr algn="ctr"/>
+            <a:endParaRPr/>
           </a:p>
         </p:txBody>
       </p:sp>
@@ -5258,7 +5352,7 @@
         <p:spPr>
           <a:xfrm>
             <a:off x="786384" y="1938528"/>
-            <a:ext cx="2276856" cy="914400"/>
+            <a:ext cx="2276856" cy="877163"/>
           </a:xfrm>
           <a:prstGeom prst="rect">
             <a:avLst/>
@@ -5277,7 +5371,7 @@
               </a:spcAft>
             </a:pPr>
             <a:r>
-              <a:rPr sz="1100" b="1">
+              <a:rPr sz="1200" b="1" dirty="0">
                 <a:solidFill>
                   <a:srgbClr val="20C9DA"/>
                 </a:solidFill>
@@ -5293,7 +5387,7 @@
               </a:spcAft>
             </a:pPr>
             <a:r>
-              <a:rPr sz="2100" b="1">
+              <a:rPr sz="2400" b="1" dirty="0">
                 <a:solidFill>
                   <a:srgbClr val="F4F8FF"/>
                 </a:solidFill>
@@ -5309,7 +5403,7 @@
               </a:spcAft>
             </a:pPr>
             <a:r>
-              <a:rPr sz="900" b="0">
+              <a:rPr sz="1000" b="0" dirty="0">
                 <a:solidFill>
                   <a:srgbClr val="B7C2D7"/>
                 </a:solidFill>
@@ -5362,6 +5456,7 @@
           <a:lstStyle/>
           <a:p>
             <a:pPr algn="ctr"/>
+            <a:endParaRPr/>
           </a:p>
         </p:txBody>
       </p:sp>
@@ -5374,7 +5469,7 @@
         <p:spPr>
           <a:xfrm>
             <a:off x="3474720" y="1938528"/>
-            <a:ext cx="2276856" cy="914400"/>
+            <a:ext cx="2276856" cy="884858"/>
           </a:xfrm>
           <a:prstGeom prst="rect">
             <a:avLst/>
@@ -5393,7 +5488,7 @@
               </a:spcAft>
             </a:pPr>
             <a:r>
-              <a:rPr sz="1100" b="1">
+              <a:rPr sz="1200" b="1">
                 <a:solidFill>
                   <a:srgbClr val="F5B335"/>
                 </a:solidFill>
@@ -5409,7 +5504,7 @@
               </a:spcAft>
             </a:pPr>
             <a:r>
-              <a:rPr sz="2100" b="1">
+              <a:rPr sz="2400" b="1">
                 <a:solidFill>
                   <a:srgbClr val="F4F8FF"/>
                 </a:solidFill>
@@ -5425,7 +5520,7 @@
               </a:spcAft>
             </a:pPr>
             <a:r>
-              <a:rPr sz="900" b="0">
+              <a:rPr sz="1000" b="0">
                 <a:solidFill>
                   <a:srgbClr val="B7C2D7"/>
                 </a:solidFill>
@@ -5478,6 +5573,7 @@
           <a:lstStyle/>
           <a:p>
             <a:pPr algn="ctr"/>
+            <a:endParaRPr/>
           </a:p>
         </p:txBody>
       </p:sp>
@@ -5490,7 +5586,7 @@
         <p:spPr>
           <a:xfrm>
             <a:off x="6163056" y="1938528"/>
-            <a:ext cx="2276856" cy="914400"/>
+            <a:ext cx="2276856" cy="884858"/>
           </a:xfrm>
           <a:prstGeom prst="rect">
             <a:avLst/>
@@ -5509,7 +5605,7 @@
               </a:spcAft>
             </a:pPr>
             <a:r>
-              <a:rPr sz="1100" b="1">
+              <a:rPr sz="1200" b="1">
                 <a:solidFill>
                   <a:srgbClr val="FF6B6B"/>
                 </a:solidFill>
@@ -5525,7 +5621,7 @@
               </a:spcAft>
             </a:pPr>
             <a:r>
-              <a:rPr sz="2100" b="1">
+              <a:rPr sz="2400" b="1">
                 <a:solidFill>
                   <a:srgbClr val="F4F8FF"/>
                 </a:solidFill>
@@ -5541,7 +5637,7 @@
               </a:spcAft>
             </a:pPr>
             <a:r>
-              <a:rPr sz="900" b="0">
+              <a:rPr sz="1000" b="0">
                 <a:solidFill>
                   <a:srgbClr val="B7C2D7"/>
                 </a:solidFill>
@@ -5594,6 +5690,7 @@
           <a:lstStyle/>
           <a:p>
             <a:pPr algn="ctr"/>
+            <a:endParaRPr/>
           </a:p>
         </p:txBody>
       </p:sp>
@@ -5606,7 +5703,7 @@
         <p:spPr>
           <a:xfrm>
             <a:off x="8851392" y="1938528"/>
-            <a:ext cx="2276856" cy="914400"/>
+            <a:ext cx="2276856" cy="884858"/>
           </a:xfrm>
           <a:prstGeom prst="rect">
             <a:avLst/>
@@ -5625,7 +5722,7 @@
               </a:spcAft>
             </a:pPr>
             <a:r>
-              <a:rPr sz="1100" b="1">
+              <a:rPr sz="1200" b="1">
                 <a:solidFill>
                   <a:srgbClr val="20C9DA"/>
                 </a:solidFill>
@@ -5641,7 +5738,7 @@
               </a:spcAft>
             </a:pPr>
             <a:r>
-              <a:rPr sz="2100" b="1">
+              <a:rPr sz="2400" b="1">
                 <a:solidFill>
                   <a:srgbClr val="F4F8FF"/>
                 </a:solidFill>
@@ -5657,7 +5754,7 @@
               </a:spcAft>
             </a:pPr>
             <a:r>
-              <a:rPr sz="900" b="0">
+              <a:rPr sz="1000" b="0">
                 <a:solidFill>
                   <a:srgbClr val="B7C2D7"/>
                 </a:solidFill>
@@ -5710,6 +5807,7 @@
           <a:lstStyle/>
           <a:p>
             <a:pPr algn="ctr"/>
+            <a:endParaRPr/>
           </a:p>
         </p:txBody>
       </p:sp>
@@ -5741,7 +5839,7 @@
               </a:spcAft>
             </a:pPr>
             <a:r>
-              <a:rPr sz="1300" b="1">
+              <a:rPr sz="1400" b="1">
                 <a:solidFill>
                   <a:srgbClr val="F5B335"/>
                 </a:solidFill>
@@ -5761,7 +5859,7 @@
         <p:spPr>
           <a:xfrm>
             <a:off x="822960" y="3867912"/>
-            <a:ext cx="3227832" cy="1417320"/>
+            <a:ext cx="3227832" cy="1328569"/>
           </a:xfrm>
           <a:prstGeom prst="rect">
             <a:avLst/>
@@ -5774,10 +5872,12 @@
           </a:bodyPr>
           <a:lstStyle/>
           <a:p>
-            <a:pPr>
+            <a:pPr marL="171450" indent="-171450">
               <a:spcAft>
                 <a:spcPts val="500"/>
               </a:spcAft>
+              <a:buFont typeface="Arial" panose="020B0604020202020204" pitchFamily="34" charset="0"/>
+              <a:buChar char="•"/>
               <a:defRPr sz="1100">
                 <a:solidFill>
                   <a:srgbClr val="F4F8FF"/>
@@ -5786,14 +5886,17 @@
               </a:defRPr>
             </a:pPr>
             <a:r>
+              <a:rPr sz="1200" dirty="0"/>
               <a:t>Input is only the mounted request table and image bundle.</a:t>
             </a:r>
           </a:p>
           <a:p>
-            <a:pPr>
+            <a:pPr marL="171450" indent="-171450">
               <a:spcAft>
                 <a:spcPts val="500"/>
               </a:spcAft>
+              <a:buFont typeface="Arial" panose="020B0604020202020204" pitchFamily="34" charset="0"/>
+              <a:buChar char="•"/>
               <a:defRPr sz="1100">
                 <a:solidFill>
                   <a:srgbClr val="F4F8FF"/>
@@ -5802,14 +5905,17 @@
               </a:defRPr>
             </a:pPr>
             <a:r>
+              <a:rPr sz="1200" dirty="0"/>
               <a:t>Output is two compact JSON files, not raw image retransmission.</a:t>
             </a:r>
           </a:p>
           <a:p>
-            <a:pPr>
+            <a:pPr marL="171450" indent="-171450">
               <a:spcAft>
                 <a:spcPts val="500"/>
               </a:spcAft>
+              <a:buFont typeface="Arial" panose="020B0604020202020204" pitchFamily="34" charset="0"/>
+              <a:buChar char="•"/>
               <a:defRPr sz="1100">
                 <a:solidFill>
                   <a:srgbClr val="F4F8FF"/>
@@ -5818,6 +5924,7 @@
               </a:defRPr>
             </a:pPr>
             <a:r>
+              <a:rPr sz="1200" dirty="0"/>
               <a:t>This supports a downlink-first product mindset.</a:t>
             </a:r>
           </a:p>
@@ -5865,6 +5972,7 @@
           <a:lstStyle/>
           <a:p>
             <a:pPr algn="ctr"/>
+            <a:endParaRPr/>
           </a:p>
         </p:txBody>
       </p:sp>
@@ -5896,7 +6004,7 @@
               </a:spcAft>
             </a:pPr>
             <a:r>
-              <a:rPr sz="1300" b="1">
+              <a:rPr sz="1400" b="1">
                 <a:solidFill>
                   <a:srgbClr val="F5B335"/>
                 </a:solidFill>
@@ -5916,7 +6024,7 @@
         <p:spPr>
           <a:xfrm>
             <a:off x="4517136" y="3867912"/>
-            <a:ext cx="3227832" cy="1417320"/>
+            <a:ext cx="3227832" cy="1328569"/>
           </a:xfrm>
           <a:prstGeom prst="rect">
             <a:avLst/>
@@ -5929,10 +6037,12 @@
           </a:bodyPr>
           <a:lstStyle/>
           <a:p>
-            <a:pPr>
+            <a:pPr marL="171450" indent="-171450">
               <a:spcAft>
                 <a:spcPts val="500"/>
               </a:spcAft>
+              <a:buFont typeface="Arial" panose="020B0604020202020204" pitchFamily="34" charset="0"/>
+              <a:buChar char="•"/>
               <a:defRPr sz="1100">
                 <a:solidFill>
                   <a:srgbClr val="F4F8FF"/>
@@ -5941,14 +6051,17 @@
               </a:defRPr>
             </a:pPr>
             <a:r>
+              <a:rPr sz="1200" dirty="0"/>
               <a:t>Models are preloaded in the image; no runtime downloads are needed.</a:t>
             </a:r>
           </a:p>
           <a:p>
-            <a:pPr>
+            <a:pPr marL="171450" indent="-171450">
               <a:spcAft>
                 <a:spcPts val="500"/>
               </a:spcAft>
+              <a:buFont typeface="Arial" panose="020B0604020202020204" pitchFamily="34" charset="0"/>
+              <a:buChar char="•"/>
               <a:defRPr sz="1100">
                 <a:solidFill>
                   <a:srgbClr val="F4F8FF"/>
@@ -5957,14 +6070,17 @@
               </a:defRPr>
             </a:pPr>
             <a:r>
+              <a:rPr sz="1200" dirty="0"/>
               <a:t>Optional CNNs stay outside the default inference path.</a:t>
             </a:r>
           </a:p>
           <a:p>
-            <a:pPr>
+            <a:pPr marL="171450" indent="-171450">
               <a:spcAft>
                 <a:spcPts val="500"/>
               </a:spcAft>
+              <a:buFont typeface="Arial" panose="020B0604020202020204" pitchFamily="34" charset="0"/>
+              <a:buChar char="•"/>
               <a:defRPr sz="1100">
                 <a:solidFill>
                   <a:srgbClr val="F4F8FF"/>
@@ -5973,6 +6089,7 @@
               </a:defRPr>
             </a:pPr>
             <a:r>
+              <a:rPr sz="1200" dirty="0"/>
               <a:t>If model loading fails, inference falls back to safe defaults instead of crashing silently.</a:t>
             </a:r>
           </a:p>
@@ -6020,6 +6137,7 @@
           <a:lstStyle/>
           <a:p>
             <a:pPr algn="ctr"/>
+            <a:endParaRPr/>
           </a:p>
         </p:txBody>
       </p:sp>
@@ -6051,7 +6169,7 @@
               </a:spcAft>
             </a:pPr>
             <a:r>
-              <a:rPr sz="1300" b="1">
+              <a:rPr sz="1400" b="1">
                 <a:solidFill>
                   <a:srgbClr val="F5B335"/>
                 </a:solidFill>
@@ -6071,7 +6189,7 @@
         <p:spPr>
           <a:xfrm>
             <a:off x="8211312" y="3867912"/>
-            <a:ext cx="3227832" cy="1417320"/>
+            <a:ext cx="3227832" cy="1513235"/>
           </a:xfrm>
           <a:prstGeom prst="rect">
             <a:avLst/>
@@ -6084,10 +6202,12 @@
           </a:bodyPr>
           <a:lstStyle/>
           <a:p>
-            <a:pPr>
+            <a:pPr marL="171450" indent="-171450">
               <a:spcAft>
                 <a:spcPts val="500"/>
               </a:spcAft>
+              <a:buFont typeface="Arial" panose="020B0604020202020204" pitchFamily="34" charset="0"/>
+              <a:buChar char="•"/>
               <a:defRPr sz="1100">
                 <a:solidFill>
                   <a:srgbClr val="F4F8FF"/>
@@ -6096,14 +6216,17 @@
               </a:defRPr>
             </a:pPr>
             <a:r>
+              <a:rPr sz="1200" dirty="0"/>
               <a:t>The final frozen runtime is compact enough to reason about as an onboard service block.</a:t>
             </a:r>
           </a:p>
           <a:p>
-            <a:pPr>
+            <a:pPr marL="171450" indent="-171450">
               <a:spcAft>
                 <a:spcPts val="500"/>
               </a:spcAft>
+              <a:buFont typeface="Arial" panose="020B0604020202020204" pitchFamily="34" charset="0"/>
+              <a:buChar char="•"/>
               <a:defRPr sz="1100">
                 <a:solidFill>
                   <a:srgbClr val="F4F8FF"/>
@@ -6112,14 +6235,17 @@
               </a:defRPr>
             </a:pPr>
             <a:r>
+              <a:rPr sz="1200" dirty="0"/>
               <a:t>What matters is that the core inference path is bounded, portable, and auditable.</a:t>
             </a:r>
           </a:p>
           <a:p>
-            <a:pPr>
+            <a:pPr marL="171450" indent="-171450">
               <a:spcAft>
                 <a:spcPts val="500"/>
               </a:spcAft>
+              <a:buFont typeface="Arial" panose="020B0604020202020204" pitchFamily="34" charset="0"/>
+              <a:buChar char="•"/>
               <a:defRPr sz="1100">
                 <a:solidFill>
                   <a:srgbClr val="F4F8FF"/>
@@ -6128,6 +6254,7 @@
               </a:defRPr>
             </a:pPr>
             <a:r>
+              <a:rPr sz="1200" dirty="0"/>
               <a:t>That is easier to harden than a CNN-only submission path.</a:t>
             </a:r>
           </a:p>
@@ -6177,7 +6304,7 @@
 </file>
 
 <file path=ppt/slides/slide4.xml><?xml version="1.0" encoding="utf-8"?>
-<p:sld xmlns:a="http://schemas.openxmlformats.org/drawingml/2006/main" xmlns:p="http://schemas.openxmlformats.org/presentationml/2006/main" xmlns:r="http://schemas.openxmlformats.org/officeDocument/2006/relationships">
+<p:sld xmlns:a="http://schemas.openxmlformats.org/drawingml/2006/main" xmlns:r="http://schemas.openxmlformats.org/officeDocument/2006/relationships" xmlns:p="http://schemas.openxmlformats.org/presentationml/2006/main">
   <p:cSld>
     <p:bg>
       <p:bgPr>
@@ -6193,7 +6320,14 @@
         <p:cNvGrpSpPr/>
         <p:nvPr/>
       </p:nvGrpSpPr>
-      <p:grpSpPr/>
+      <p:grpSpPr>
+        <a:xfrm>
+          <a:off x="0" y="0"/>
+          <a:ext cx="0" cy="0"/>
+          <a:chOff x="0" y="0"/>
+          <a:chExt cx="0" cy="0"/>
+        </a:xfrm>
+      </p:grpSpPr>
       <p:sp>
         <p:nvSpPr>
           <p:cNvPr id="2" name="Rounded Rectangle 1"/>
@@ -6257,7 +6391,7 @@
         <p:spPr>
           <a:xfrm>
             <a:off x="548640" y="749808"/>
-            <a:ext cx="7589520" cy="822960"/>
+            <a:ext cx="6830652" cy="584775"/>
           </a:xfrm>
           <a:prstGeom prst="rect">
             <a:avLst/>
@@ -6271,7 +6405,7 @@
           <a:lstStyle/>
           <a:p>
             <a:r>
-              <a:rPr sz="2500" b="1">
+              <a:rPr sz="3200" b="1">
                 <a:solidFill>
                   <a:srgbClr val="F4F8FF"/>
                 </a:solidFill>
@@ -6290,8 +6424,8 @@
         </p:nvSpPr>
         <p:spPr>
           <a:xfrm>
-            <a:off x="566928" y="1444752"/>
-            <a:ext cx="8046720" cy="438912"/>
+            <a:off x="640080" y="1180694"/>
+            <a:ext cx="5704960" cy="307777"/>
           </a:xfrm>
           <a:prstGeom prst="rect">
             <a:avLst/>
@@ -6305,7 +6439,7 @@
           <a:lstStyle/>
           <a:p>
             <a:r>
-              <a:rPr sz="1150">
+              <a:rPr sz="1400" dirty="0">
                 <a:solidFill>
                   <a:srgbClr val="B7C2D7"/>
                 </a:solidFill>
@@ -6358,6 +6492,7 @@
           <a:lstStyle/>
           <a:p>
             <a:pPr algn="ctr"/>
+            <a:endParaRPr/>
           </a:p>
         </p:txBody>
       </p:sp>
@@ -6370,7 +6505,7 @@
         <p:spPr>
           <a:xfrm>
             <a:off x="868680" y="1993392"/>
-            <a:ext cx="4754880" cy="4023360"/>
+            <a:ext cx="4754880" cy="1777410"/>
           </a:xfrm>
           <a:prstGeom prst="rect">
             <a:avLst/>
@@ -6389,7 +6524,7 @@
               </a:spcAft>
             </a:pPr>
             <a:r>
-              <a:rPr sz="1400" b="1">
+              <a:rPr b="1" dirty="0">
                 <a:solidFill>
                   <a:srgbClr val="FF6B6B"/>
                 </a:solidFill>
@@ -6399,13 +6534,15 @@
             </a:r>
           </a:p>
           <a:p>
-            <a:pPr algn="l">
+            <a:pPr marL="285750" indent="-285750" algn="l">
               <a:spcAft>
                 <a:spcPts val="300"/>
               </a:spcAft>
-            </a:pPr>
-            <a:r>
-              <a:rPr sz="1100" b="0">
+              <a:buFont typeface="Arial" panose="020B0604020202020204" pitchFamily="34" charset="0"/>
+              <a:buChar char="•"/>
+            </a:pPr>
+            <a:r>
+              <a:rPr sz="1400" b="0" dirty="0">
                 <a:solidFill>
                   <a:srgbClr val="B7C2D7"/>
                 </a:solidFill>
@@ -6415,13 +6552,15 @@
             </a:r>
           </a:p>
           <a:p>
-            <a:pPr algn="l">
+            <a:pPr marL="285750" indent="-285750" algn="l">
               <a:spcAft>
                 <a:spcPts val="300"/>
               </a:spcAft>
-            </a:pPr>
-            <a:r>
-              <a:rPr sz="1100" b="0">
+              <a:buFont typeface="Arial" panose="020B0604020202020204" pitchFamily="34" charset="0"/>
+              <a:buChar char="•"/>
+            </a:pPr>
+            <a:r>
+              <a:rPr sz="1400" b="0" dirty="0">
                 <a:solidFill>
                   <a:srgbClr val="B7C2D7"/>
                 </a:solidFill>
@@ -6431,13 +6570,15 @@
             </a:r>
           </a:p>
           <a:p>
-            <a:pPr algn="l">
+            <a:pPr marL="285750" indent="-285750" algn="l">
               <a:spcAft>
                 <a:spcPts val="300"/>
               </a:spcAft>
-            </a:pPr>
-            <a:r>
-              <a:rPr sz="1100" b="0">
+              <a:buFont typeface="Arial" panose="020B0604020202020204" pitchFamily="34" charset="0"/>
+              <a:buChar char="•"/>
+            </a:pPr>
+            <a:r>
+              <a:rPr sz="1400" b="0" dirty="0">
                 <a:solidFill>
                   <a:srgbClr val="B7C2D7"/>
                 </a:solidFill>
@@ -6490,6 +6631,7 @@
           <a:lstStyle/>
           <a:p>
             <a:pPr algn="ctr"/>
+            <a:endParaRPr/>
           </a:p>
         </p:txBody>
       </p:sp>
@@ -6502,7 +6644,7 @@
         <p:spPr>
           <a:xfrm>
             <a:off x="6382512" y="1993392"/>
-            <a:ext cx="4892040" cy="4023360"/>
+            <a:ext cx="4892040" cy="2716128"/>
           </a:xfrm>
           <a:prstGeom prst="rect">
             <a:avLst/>
@@ -6521,23 +6663,34 @@
               </a:spcAft>
             </a:pPr>
             <a:r>
-              <a:rPr sz="1400" b="1">
+              <a:rPr b="1" dirty="0" err="1">
                 <a:solidFill>
                   <a:srgbClr val="20C9DA"/>
                 </a:solidFill>
                 <a:latin typeface="Aptos"/>
               </a:rPr>
-              <a:t>HydroSat path</a:t>
-            </a:r>
-          </a:p>
-          <a:p>
-            <a:pPr algn="l">
+              <a:t>HydroSat</a:t>
+            </a:r>
+            <a:r>
+              <a:rPr b="1" dirty="0">
+                <a:solidFill>
+                  <a:srgbClr val="20C9DA"/>
+                </a:solidFill>
+                <a:latin typeface="Aptos"/>
+              </a:rPr>
+              <a:t> path</a:t>
+            </a:r>
+          </a:p>
+          <a:p>
+            <a:pPr marL="285750" indent="-285750" algn="l">
               <a:spcAft>
                 <a:spcPts val="300"/>
               </a:spcAft>
-            </a:pPr>
-            <a:r>
-              <a:rPr sz="1100" b="0">
+              <a:buFont typeface="Arial" panose="020B0604020202020204" pitchFamily="34" charset="0"/>
+              <a:buChar char="•"/>
+            </a:pPr>
+            <a:r>
+              <a:rPr sz="1400" b="0" dirty="0">
                 <a:solidFill>
                   <a:srgbClr val="F4F8FF"/>
                 </a:solidFill>
@@ -6547,29 +6700,51 @@
             </a:r>
           </a:p>
           <a:p>
-            <a:pPr algn="l">
+            <a:pPr marL="285750" indent="-285750" algn="l">
               <a:spcAft>
                 <a:spcPts val="300"/>
               </a:spcAft>
-            </a:pPr>
-            <a:r>
-              <a:rPr sz="1100" b="0">
+              <a:buFont typeface="Arial" panose="020B0604020202020204" pitchFamily="34" charset="0"/>
+              <a:buChar char="•"/>
+            </a:pPr>
+            <a:r>
+              <a:rPr sz="1400" b="0" dirty="0">
                 <a:solidFill>
                   <a:srgbClr val="F4F8FF"/>
                 </a:solidFill>
                 <a:latin typeface="Aptos"/>
               </a:rPr>
-              <a:t>Separate turbidity and chl-a inference so each target can follow a different feature importance pattern.</a:t>
-            </a:r>
-          </a:p>
-          <a:p>
-            <a:pPr algn="l">
+              <a:t>Separate turbidity and </a:t>
+            </a:r>
+            <a:r>
+              <a:rPr sz="1400" b="0" dirty="0" err="1">
+                <a:solidFill>
+                  <a:srgbClr val="F4F8FF"/>
+                </a:solidFill>
+                <a:latin typeface="Aptos"/>
+              </a:rPr>
+              <a:t>chl</a:t>
+            </a:r>
+            <a:r>
+              <a:rPr sz="1400" b="0" dirty="0">
+                <a:solidFill>
+                  <a:srgbClr val="F4F8FF"/>
+                </a:solidFill>
+                <a:latin typeface="Aptos"/>
+              </a:rPr>
+              <a:t>-a inference so each target can follow a different feature importance pattern.</a:t>
+            </a:r>
+          </a:p>
+          <a:p>
+            <a:pPr marL="285750" indent="-285750" algn="l">
               <a:spcAft>
                 <a:spcPts val="300"/>
               </a:spcAft>
-            </a:pPr>
-            <a:r>
-              <a:rPr sz="1100" b="0">
+              <a:buFont typeface="Arial" panose="020B0604020202020204" pitchFamily="34" charset="0"/>
+              <a:buChar char="•"/>
+            </a:pPr>
+            <a:r>
+              <a:rPr sz="1400" b="0" dirty="0">
                 <a:solidFill>
                   <a:srgbClr val="F4F8FF"/>
                 </a:solidFill>
@@ -6579,13 +6754,15 @@
             </a:r>
           </a:p>
           <a:p>
-            <a:pPr algn="l">
+            <a:pPr marL="285750" indent="-285750" algn="l">
               <a:spcAft>
                 <a:spcPts val="300"/>
               </a:spcAft>
-            </a:pPr>
-            <a:r>
-              <a:rPr sz="1100" b="0">
+              <a:buFont typeface="Arial" panose="020B0604020202020204" pitchFamily="34" charset="0"/>
+              <a:buChar char="•"/>
+            </a:pPr>
+            <a:r>
+              <a:rPr sz="1400" b="0" dirty="0">
                 <a:solidFill>
                   <a:srgbClr val="F4F8FF"/>
                 </a:solidFill>
@@ -6595,13 +6772,15 @@
             </a:r>
           </a:p>
           <a:p>
-            <a:pPr algn="l">
+            <a:pPr marL="285750" indent="-285750" algn="l">
               <a:spcAft>
                 <a:spcPts val="300"/>
               </a:spcAft>
-            </a:pPr>
-            <a:r>
-              <a:rPr sz="1100" b="0">
+              <a:buFont typeface="Arial" panose="020B0604020202020204" pitchFamily="34" charset="0"/>
+              <a:buChar char="•"/>
+            </a:pPr>
+            <a:r>
+              <a:rPr sz="1400" b="0" dirty="0">
                 <a:solidFill>
                   <a:srgbClr val="F4F8FF"/>
                 </a:solidFill>
@@ -6620,7 +6799,7 @@
         </p:nvSpPr>
         <p:spPr>
           <a:xfrm>
-            <a:off x="868680" y="5577840"/>
+            <a:off x="870246" y="5202936"/>
             <a:ext cx="2240280" cy="384048"/>
           </a:xfrm>
           <a:prstGeom prst="roundRect">
@@ -6655,7 +6834,7 @@
           <a:p>
             <a:pPr algn="ctr"/>
             <a:r>
-              <a:rPr sz="1000" b="1">
+              <a:rPr sz="1200" b="1">
                 <a:solidFill>
                   <a:srgbClr val="F4F8FF"/>
                 </a:solidFill>
@@ -6674,7 +6853,7 @@
         </p:nvSpPr>
         <p:spPr>
           <a:xfrm>
-            <a:off x="3611880" y="5577840"/>
+            <a:off x="3403134" y="5202936"/>
             <a:ext cx="2240280" cy="384048"/>
           </a:xfrm>
           <a:prstGeom prst="roundRect">
@@ -6709,7 +6888,7 @@
           <a:p>
             <a:pPr algn="ctr"/>
             <a:r>
-              <a:rPr sz="1000" b="1">
+              <a:rPr sz="1200" b="1">
                 <a:solidFill>
                   <a:srgbClr val="F4F8FF"/>
                 </a:solidFill>
@@ -6728,7 +6907,7 @@
         </p:nvSpPr>
         <p:spPr>
           <a:xfrm>
-            <a:off x="6355080" y="5577840"/>
+            <a:off x="6382512" y="5202936"/>
             <a:ext cx="2240280" cy="384048"/>
           </a:xfrm>
           <a:prstGeom prst="roundRect">
@@ -6763,7 +6942,7 @@
           <a:p>
             <a:pPr algn="ctr"/>
             <a:r>
-              <a:rPr sz="1000" b="1">
+              <a:rPr sz="1200" b="1">
                 <a:solidFill>
                   <a:srgbClr val="F4F8FF"/>
                 </a:solidFill>
@@ -6782,7 +6961,7 @@
         </p:nvSpPr>
         <p:spPr>
           <a:xfrm>
-            <a:off x="9098280" y="5577840"/>
+            <a:off x="9098280" y="5202936"/>
             <a:ext cx="2240280" cy="384048"/>
           </a:xfrm>
           <a:prstGeom prst="roundRect">
@@ -6817,7 +6996,7 @@
           <a:p>
             <a:pPr algn="ctr"/>
             <a:r>
-              <a:rPr sz="1000" b="1">
+              <a:rPr sz="1200" b="1">
                 <a:solidFill>
                   <a:srgbClr val="F4F8FF"/>
                 </a:solidFill>
@@ -6872,7 +7051,7 @@
 </file>
 
 <file path=ppt/slides/slide5.xml><?xml version="1.0" encoding="utf-8"?>
-<p:sld xmlns:a="http://schemas.openxmlformats.org/drawingml/2006/main" xmlns:p="http://schemas.openxmlformats.org/presentationml/2006/main" xmlns:r="http://schemas.openxmlformats.org/officeDocument/2006/relationships">
+<p:sld xmlns:a="http://schemas.openxmlformats.org/drawingml/2006/main" xmlns:r="http://schemas.openxmlformats.org/officeDocument/2006/relationships" xmlns:p="http://schemas.openxmlformats.org/presentationml/2006/main">
   <p:cSld>
     <p:bg>
       <p:bgPr>
@@ -6888,7 +7067,14 @@
         <p:cNvGrpSpPr/>
         <p:nvPr/>
       </p:nvGrpSpPr>
-      <p:grpSpPr/>
+      <p:grpSpPr>
+        <a:xfrm>
+          <a:off x="0" y="0"/>
+          <a:ext cx="0" cy="0"/>
+          <a:chOff x="0" y="0"/>
+          <a:chExt cx="0" cy="0"/>
+        </a:xfrm>
+      </p:grpSpPr>
       <p:sp>
         <p:nvSpPr>
           <p:cNvPr id="2" name="Rounded Rectangle 1"/>
@@ -6952,7 +7138,7 @@
         <p:spPr>
           <a:xfrm>
             <a:off x="548640" y="749808"/>
-            <a:ext cx="7589520" cy="822960"/>
+            <a:ext cx="4972130" cy="584775"/>
           </a:xfrm>
           <a:prstGeom prst="rect">
             <a:avLst/>
@@ -6966,7 +7152,7 @@
           <a:lstStyle/>
           <a:p>
             <a:r>
-              <a:rPr sz="2500" b="1">
+              <a:rPr sz="3200" b="1">
                 <a:solidFill>
                   <a:srgbClr val="F4F8FF"/>
                 </a:solidFill>
@@ -6985,8 +7171,8 @@
         </p:nvSpPr>
         <p:spPr>
           <a:xfrm>
-            <a:off x="566928" y="1444752"/>
-            <a:ext cx="8046720" cy="438912"/>
+            <a:off x="640080" y="1179577"/>
+            <a:ext cx="7397474" cy="307777"/>
           </a:xfrm>
           <a:prstGeom prst="rect">
             <a:avLst/>
@@ -7000,7 +7186,7 @@
           <a:lstStyle/>
           <a:p>
             <a:r>
-              <a:rPr sz="1150">
+              <a:rPr sz="1400" dirty="0">
                 <a:solidFill>
                   <a:srgbClr val="B7C2D7"/>
                 </a:solidFill>
@@ -7053,6 +7239,7 @@
           <a:lstStyle/>
           <a:p>
             <a:pPr algn="ctr"/>
+            <a:endParaRPr/>
           </a:p>
         </p:txBody>
       </p:sp>
@@ -7065,7 +7252,7 @@
         <p:spPr>
           <a:xfrm>
             <a:off x="804672" y="1956816"/>
-            <a:ext cx="2048256" cy="914400"/>
+            <a:ext cx="2048256" cy="969496"/>
           </a:xfrm>
           <a:prstGeom prst="rect">
             <a:avLst/>
@@ -7084,7 +7271,7 @@
               </a:spcAft>
             </a:pPr>
             <a:r>
-              <a:rPr sz="1100" b="1">
+              <a:rPr sz="1400" b="1" dirty="0">
                 <a:solidFill>
                   <a:srgbClr val="FF6B6B"/>
                 </a:solidFill>
@@ -7100,7 +7287,7 @@
               </a:spcAft>
             </a:pPr>
             <a:r>
-              <a:rPr sz="2100" b="1">
+              <a:rPr sz="2800" b="1" dirty="0">
                 <a:solidFill>
                   <a:srgbClr val="F4F8FF"/>
                 </a:solidFill>
@@ -7116,7 +7303,7 @@
               </a:spcAft>
             </a:pPr>
             <a:r>
-              <a:rPr sz="900" b="0">
+              <a:rPr sz="1050" b="0" dirty="0">
                 <a:solidFill>
                   <a:srgbClr val="B7C2D7"/>
                 </a:solidFill>
@@ -7169,6 +7356,7 @@
           <a:lstStyle/>
           <a:p>
             <a:pPr algn="ctr"/>
+            <a:endParaRPr/>
           </a:p>
         </p:txBody>
       </p:sp>
@@ -7181,7 +7369,7 @@
         <p:spPr>
           <a:xfrm>
             <a:off x="804672" y="3291840"/>
-            <a:ext cx="2048256" cy="914400"/>
+            <a:ext cx="2048256" cy="969496"/>
           </a:xfrm>
           <a:prstGeom prst="rect">
             <a:avLst/>
@@ -7200,7 +7388,7 @@
               </a:spcAft>
             </a:pPr>
             <a:r>
-              <a:rPr sz="1100" b="1">
+              <a:rPr sz="1400" b="1">
                 <a:solidFill>
                   <a:srgbClr val="20C9DA"/>
                 </a:solidFill>
@@ -7216,7 +7404,7 @@
               </a:spcAft>
             </a:pPr>
             <a:r>
-              <a:rPr sz="2100" b="1">
+              <a:rPr sz="2800" b="1">
                 <a:solidFill>
                   <a:srgbClr val="F4F8FF"/>
                 </a:solidFill>
@@ -7232,7 +7420,7 @@
               </a:spcAft>
             </a:pPr>
             <a:r>
-              <a:rPr sz="900" b="0">
+              <a:rPr sz="1050" b="0">
                 <a:solidFill>
                   <a:srgbClr val="B7C2D7"/>
                 </a:solidFill>
@@ -7285,6 +7473,7 @@
           <a:lstStyle/>
           <a:p>
             <a:pPr algn="ctr"/>
+            <a:endParaRPr/>
           </a:p>
         </p:txBody>
       </p:sp>
@@ -7297,7 +7486,7 @@
         <p:spPr>
           <a:xfrm>
             <a:off x="804672" y="4626864"/>
-            <a:ext cx="2048256" cy="914400"/>
+            <a:ext cx="2048256" cy="969496"/>
           </a:xfrm>
           <a:prstGeom prst="rect">
             <a:avLst/>
@@ -7316,7 +7505,7 @@
               </a:spcAft>
             </a:pPr>
             <a:r>
-              <a:rPr sz="1100" b="1">
+              <a:rPr sz="1400" b="1">
                 <a:solidFill>
                   <a:srgbClr val="F5B335"/>
                 </a:solidFill>
@@ -7332,7 +7521,7 @@
               </a:spcAft>
             </a:pPr>
             <a:r>
-              <a:rPr sz="2100" b="1">
+              <a:rPr sz="2800" b="1">
                 <a:solidFill>
                   <a:srgbClr val="F4F8FF"/>
                 </a:solidFill>
@@ -7348,7 +7537,7 @@
               </a:spcAft>
             </a:pPr>
             <a:r>
-              <a:rPr sz="900" b="0">
+              <a:rPr sz="1050" b="0">
                 <a:solidFill>
                   <a:srgbClr val="B7C2D7"/>
                 </a:solidFill>
@@ -7401,6 +7590,7 @@
           <a:lstStyle/>
           <a:p>
             <a:pPr algn="ctr"/>
+            <a:endParaRPr/>
           </a:p>
         </p:txBody>
       </p:sp>
@@ -7412,8 +7602,8 @@
         </p:nvSpPr>
         <p:spPr>
           <a:xfrm>
-            <a:off x="3438144" y="1956816"/>
-            <a:ext cx="3465576" cy="320040"/>
+            <a:off x="3429000" y="2708122"/>
+            <a:ext cx="3465576" cy="338554"/>
           </a:xfrm>
           <a:prstGeom prst="rect">
             <a:avLst/>
@@ -7432,7 +7622,7 @@
               </a:spcAft>
             </a:pPr>
             <a:r>
-              <a:rPr sz="1300" b="1">
+              <a:rPr sz="1600" b="1" dirty="0">
                 <a:solidFill>
                   <a:srgbClr val="F5B335"/>
                 </a:solidFill>
@@ -7451,8 +7641,8 @@
         </p:nvSpPr>
         <p:spPr>
           <a:xfrm>
-            <a:off x="3474720" y="2286000"/>
-            <a:ext cx="3502152" cy="3428999"/>
+            <a:off x="3465576" y="3037306"/>
+            <a:ext cx="3502152" cy="2008242"/>
           </a:xfrm>
           <a:prstGeom prst="rect">
             <a:avLst/>
@@ -7465,10 +7655,12 @@
           </a:bodyPr>
           <a:lstStyle/>
           <a:p>
-            <a:pPr>
+            <a:pPr marL="285750" indent="-285750">
               <a:spcAft>
                 <a:spcPts val="500"/>
               </a:spcAft>
+              <a:buFont typeface="Arial" panose="020B0604020202020204" pitchFamily="34" charset="0"/>
+              <a:buChar char="•"/>
               <a:defRPr sz="1100">
                 <a:solidFill>
                   <a:srgbClr val="F4F8FF"/>
@@ -7477,14 +7669,17 @@
               </a:defRPr>
             </a:pPr>
             <a:r>
+              <a:rPr sz="1400" dirty="0"/>
               <a:t>Historical local measurements refine repeat-station products.</a:t>
             </a:r>
           </a:p>
           <a:p>
-            <a:pPr>
+            <a:pPr marL="285750" indent="-285750">
               <a:spcAft>
                 <a:spcPts val="500"/>
               </a:spcAft>
+              <a:buFont typeface="Arial" panose="020B0604020202020204" pitchFamily="34" charset="0"/>
+              <a:buChar char="•"/>
               <a:defRPr sz="1100">
                 <a:solidFill>
                   <a:srgbClr val="F4F8FF"/>
@@ -7493,14 +7688,17 @@
               </a:defRPr>
             </a:pPr>
             <a:r>
+              <a:rPr sz="1400" dirty="0"/>
               <a:t>Retrospective date-held-out research reached 53.95.</a:t>
             </a:r>
           </a:p>
           <a:p>
-            <a:pPr>
+            <a:pPr marL="285750" indent="-285750">
               <a:spcAft>
                 <a:spcPts val="500"/>
               </a:spcAft>
+              <a:buFont typeface="Arial" panose="020B0604020202020204" pitchFamily="34" charset="0"/>
+              <a:buChar char="•"/>
               <a:defRPr sz="1100">
                 <a:solidFill>
                   <a:srgbClr val="F4F8FF"/>
@@ -7509,14 +7707,17 @@
               </a:defRPr>
             </a:pPr>
             <a:r>
+              <a:rPr sz="1400" dirty="0"/>
               <a:t>This is not a leaderboard replacement score.</a:t>
             </a:r>
           </a:p>
           <a:p>
-            <a:pPr>
+            <a:pPr marL="285750" indent="-285750">
               <a:spcAft>
                 <a:spcPts val="500"/>
               </a:spcAft>
+              <a:buFont typeface="Arial" panose="020B0604020202020204" pitchFamily="34" charset="0"/>
+              <a:buChar char="•"/>
               <a:defRPr sz="1100">
                 <a:solidFill>
                   <a:srgbClr val="F4F8FF"/>
@@ -7525,6 +7726,7 @@
               </a:defRPr>
             </a:pPr>
             <a:r>
+              <a:rPr sz="1400" dirty="0"/>
               <a:t>It shows why the system becomes stronger after deployment.</a:t>
             </a:r>
           </a:p>
@@ -7572,6 +7774,7 @@
           <a:lstStyle/>
           <a:p>
             <a:pPr algn="ctr"/>
+            <a:endParaRPr/>
           </a:p>
         </p:txBody>
       </p:sp>
@@ -7583,8 +7786,8 @@
         </p:nvSpPr>
         <p:spPr>
           <a:xfrm>
-            <a:off x="7434072" y="1956816"/>
-            <a:ext cx="3922776" cy="320040"/>
+            <a:off x="7434072" y="2708122"/>
+            <a:ext cx="3922776" cy="338554"/>
           </a:xfrm>
           <a:prstGeom prst="rect">
             <a:avLst/>
@@ -7603,7 +7806,7 @@
               </a:spcAft>
             </a:pPr>
             <a:r>
-              <a:rPr sz="1300" b="1">
+              <a:rPr sz="1600" b="1">
                 <a:solidFill>
                   <a:srgbClr val="F5B335"/>
                 </a:solidFill>
@@ -7622,8 +7825,8 @@
         </p:nvSpPr>
         <p:spPr>
           <a:xfrm>
-            <a:off x="7470648" y="2286000"/>
-            <a:ext cx="3959352" cy="3428999"/>
+            <a:off x="7470648" y="3037306"/>
+            <a:ext cx="3959352" cy="1577355"/>
           </a:xfrm>
           <a:prstGeom prst="rect">
             <a:avLst/>
@@ -7636,10 +7839,12 @@
           </a:bodyPr>
           <a:lstStyle/>
           <a:p>
-            <a:pPr>
+            <a:pPr marL="285750" indent="-285750">
               <a:spcAft>
                 <a:spcPts val="500"/>
               </a:spcAft>
+              <a:buFont typeface="Arial" panose="020B0604020202020204" pitchFamily="34" charset="0"/>
+              <a:buChar char="•"/>
               <a:defRPr sz="1100">
                 <a:solidFill>
                   <a:srgbClr val="F4F8FF"/>
@@ -7648,14 +7853,17 @@
               </a:defRPr>
             </a:pPr>
             <a:r>
+              <a:rPr sz="1400" dirty="0"/>
               <a:t>Reservoir and river surveillance in data-sparse regions</a:t>
             </a:r>
           </a:p>
           <a:p>
-            <a:pPr>
+            <a:pPr marL="285750" indent="-285750">
               <a:spcAft>
                 <a:spcPts val="500"/>
               </a:spcAft>
+              <a:buFont typeface="Arial" panose="020B0604020202020204" pitchFamily="34" charset="0"/>
+              <a:buChar char="•"/>
               <a:defRPr sz="1100">
                 <a:solidFill>
                   <a:srgbClr val="F4F8FF"/>
@@ -7664,14 +7872,17 @@
               </a:defRPr>
             </a:pPr>
             <a:r>
+              <a:rPr sz="1400" dirty="0"/>
               <a:t>Storm-event sediment monitoring</a:t>
             </a:r>
           </a:p>
           <a:p>
-            <a:pPr>
+            <a:pPr marL="285750" indent="-285750">
               <a:spcAft>
                 <a:spcPts val="500"/>
               </a:spcAft>
+              <a:buFont typeface="Arial" panose="020B0604020202020204" pitchFamily="34" charset="0"/>
+              <a:buChar char="•"/>
               <a:defRPr sz="1100">
                 <a:solidFill>
                   <a:srgbClr val="F4F8FF"/>
@@ -7680,14 +7891,17 @@
               </a:defRPr>
             </a:pPr>
             <a:r>
+              <a:rPr sz="1400" dirty="0"/>
               <a:t>Algal bloom early warning triage</a:t>
             </a:r>
           </a:p>
           <a:p>
-            <a:pPr>
+            <a:pPr marL="285750" indent="-285750">
               <a:spcAft>
                 <a:spcPts val="500"/>
               </a:spcAft>
+              <a:buFont typeface="Arial" panose="020B0604020202020204" pitchFamily="34" charset="0"/>
+              <a:buChar char="•"/>
               <a:defRPr sz="1100">
                 <a:solidFill>
                   <a:srgbClr val="F4F8FF"/>
@@ -7696,6 +7910,7 @@
               </a:defRPr>
             </a:pPr>
             <a:r>
+              <a:rPr sz="1400" dirty="0"/>
               <a:t>Mission operations where downlink is the real bottleneck</a:t>
             </a:r>
           </a:p>
@@ -7745,7 +7960,7 @@
 </file>
 
 <file path=ppt/slides/slide6.xml><?xml version="1.0" encoding="utf-8"?>
-<p:sld xmlns:a="http://schemas.openxmlformats.org/drawingml/2006/main" xmlns:p="http://schemas.openxmlformats.org/presentationml/2006/main" xmlns:r="http://schemas.openxmlformats.org/officeDocument/2006/relationships">
+<p:sld xmlns:a="http://schemas.openxmlformats.org/drawingml/2006/main" xmlns:r="http://schemas.openxmlformats.org/officeDocument/2006/relationships" xmlns:p="http://schemas.openxmlformats.org/presentationml/2006/main">
   <p:cSld>
     <p:bg>
       <p:bgPr>
@@ -7761,7 +7976,14 @@
         <p:cNvGrpSpPr/>
         <p:nvPr/>
       </p:nvGrpSpPr>
-      <p:grpSpPr/>
+      <p:grpSpPr>
+        <a:xfrm>
+          <a:off x="0" y="0"/>
+          <a:ext cx="0" cy="0"/>
+          <a:chOff x="0" y="0"/>
+          <a:chExt cx="0" cy="0"/>
+        </a:xfrm>
+      </p:grpSpPr>
       <p:sp>
         <p:nvSpPr>
           <p:cNvPr id="2" name="Rounded Rectangle 1"/>
@@ -7825,7 +8047,7 @@
         <p:spPr>
           <a:xfrm>
             <a:off x="548640" y="749808"/>
-            <a:ext cx="7589520" cy="822960"/>
+            <a:ext cx="7689284" cy="584775"/>
           </a:xfrm>
           <a:prstGeom prst="rect">
             <a:avLst/>
@@ -7839,7 +8061,7 @@
           <a:lstStyle/>
           <a:p>
             <a:r>
-              <a:rPr sz="2500" b="1">
+              <a:rPr sz="3200" b="1">
                 <a:solidFill>
                   <a:srgbClr val="F4F8FF"/>
                 </a:solidFill>
@@ -7858,8 +8080,8 @@
         </p:nvSpPr>
         <p:spPr>
           <a:xfrm>
-            <a:off x="566928" y="1444752"/>
-            <a:ext cx="8046720" cy="438912"/>
+            <a:off x="621792" y="1179135"/>
+            <a:ext cx="7318094" cy="307777"/>
           </a:xfrm>
           <a:prstGeom prst="rect">
             <a:avLst/>
@@ -7873,7 +8095,7 @@
           <a:lstStyle/>
           <a:p>
             <a:r>
-              <a:rPr sz="1150">
+              <a:rPr sz="1400" dirty="0">
                 <a:solidFill>
                   <a:srgbClr val="B7C2D7"/>
                 </a:solidFill>
@@ -7926,6 +8148,7 @@
           <a:lstStyle/>
           <a:p>
             <a:pPr algn="ctr"/>
+            <a:endParaRPr/>
           </a:p>
         </p:txBody>
       </p:sp>
@@ -7937,8 +8160,8 @@
         </p:nvSpPr>
         <p:spPr>
           <a:xfrm>
-            <a:off x="950976" y="2286000"/>
-            <a:ext cx="2907792" cy="1965960"/>
+            <a:off x="950976" y="2496312"/>
+            <a:ext cx="2907792" cy="1300356"/>
           </a:xfrm>
           <a:prstGeom prst="rect">
             <a:avLst/>
@@ -7957,7 +8180,7 @@
               </a:spcAft>
             </a:pPr>
             <a:r>
-              <a:rPr sz="1300" b="1">
+              <a:rPr sz="2000" b="1" dirty="0">
                 <a:solidFill>
                   <a:srgbClr val="20C9DA"/>
                 </a:solidFill>
@@ -7973,7 +8196,7 @@
               </a:spcAft>
             </a:pPr>
             <a:r>
-              <a:rPr sz="1000" b="0">
+              <a:rPr sz="1400" b="0" dirty="0">
                 <a:solidFill>
                   <a:srgbClr val="F4F8FF"/>
                 </a:solidFill>
@@ -8026,6 +8249,7 @@
           <a:lstStyle/>
           <a:p>
             <a:pPr algn="ctr"/>
+            <a:endParaRPr/>
           </a:p>
         </p:txBody>
       </p:sp>
@@ -8071,6 +8295,7 @@
           <a:lstStyle/>
           <a:p>
             <a:pPr algn="ctr"/>
+            <a:endParaRPr/>
           </a:p>
         </p:txBody>
       </p:sp>
@@ -8082,8 +8307,8 @@
         </p:nvSpPr>
         <p:spPr>
           <a:xfrm>
-            <a:off x="4718304" y="2286000"/>
-            <a:ext cx="2907792" cy="1965960"/>
+            <a:off x="4718304" y="2496312"/>
+            <a:ext cx="2907792" cy="1392689"/>
           </a:xfrm>
           <a:prstGeom prst="rect">
             <a:avLst/>
@@ -8102,7 +8327,7 @@
               </a:spcAft>
             </a:pPr>
             <a:r>
-              <a:rPr sz="1300" b="1">
+              <a:rPr sz="2000" b="1">
                 <a:solidFill>
                   <a:srgbClr val="F5B335"/>
                 </a:solidFill>
@@ -8118,7 +8343,7 @@
               </a:spcAft>
             </a:pPr>
             <a:r>
-              <a:rPr sz="1000" b="0">
+              <a:rPr sz="1400" b="0">
                 <a:solidFill>
                   <a:srgbClr val="F4F8FF"/>
                 </a:solidFill>
@@ -8171,6 +8396,7 @@
           <a:lstStyle/>
           <a:p>
             <a:pPr algn="ctr"/>
+            <a:endParaRPr/>
           </a:p>
         </p:txBody>
       </p:sp>
@@ -8216,6 +8442,7 @@
           <a:lstStyle/>
           <a:p>
             <a:pPr algn="ctr"/>
+            <a:endParaRPr/>
           </a:p>
         </p:txBody>
       </p:sp>
@@ -8227,8 +8454,8 @@
         </p:nvSpPr>
         <p:spPr>
           <a:xfrm>
-            <a:off x="8485632" y="2286000"/>
-            <a:ext cx="2907792" cy="1965960"/>
+            <a:off x="8485632" y="2496312"/>
+            <a:ext cx="2907792" cy="1392689"/>
           </a:xfrm>
           <a:prstGeom prst="rect">
             <a:avLst/>
@@ -8247,7 +8474,7 @@
               </a:spcAft>
             </a:pPr>
             <a:r>
-              <a:rPr sz="1300" b="1">
+              <a:rPr sz="2000" b="1">
                 <a:solidFill>
                   <a:srgbClr val="FF6B6B"/>
                 </a:solidFill>
@@ -8263,7 +8490,7 @@
               </a:spcAft>
             </a:pPr>
             <a:r>
-              <a:rPr sz="1000" b="0">
+              <a:rPr sz="1400" b="0">
                 <a:solidFill>
                   <a:srgbClr val="F4F8FF"/>
                 </a:solidFill>
@@ -8282,8 +8509,8 @@
         </p:nvSpPr>
         <p:spPr>
           <a:xfrm>
-            <a:off x="804672" y="4892040"/>
-            <a:ext cx="10698480" cy="1051560"/>
+            <a:off x="804672" y="4773167"/>
+            <a:ext cx="10698480" cy="1462269"/>
           </a:xfrm>
           <a:prstGeom prst="roundRect">
             <a:avLst/>
@@ -8316,6 +8543,7 @@
           <a:lstStyle/>
           <a:p>
             <a:pPr algn="ctr"/>
+            <a:endParaRPr/>
           </a:p>
         </p:txBody>
       </p:sp>
@@ -8327,7 +8555,7 @@
         </p:nvSpPr>
         <p:spPr>
           <a:xfrm>
-            <a:off x="969264" y="5001768"/>
+            <a:off x="969264" y="4837176"/>
             <a:ext cx="10369296" cy="320040"/>
           </a:xfrm>
           <a:prstGeom prst="rect">
@@ -8347,7 +8575,7 @@
               </a:spcAft>
             </a:pPr>
             <a:r>
-              <a:rPr sz="1300" b="1">
+              <a:rPr sz="1400" b="1" dirty="0">
                 <a:solidFill>
                   <a:srgbClr val="F5B335"/>
                 </a:solidFill>
@@ -8366,8 +8594,8 @@
         </p:nvSpPr>
         <p:spPr>
           <a:xfrm>
-            <a:off x="1005840" y="5330952"/>
-            <a:ext cx="10405872" cy="502920"/>
+            <a:off x="1005840" y="5166360"/>
+            <a:ext cx="10405872" cy="1023357"/>
           </a:xfrm>
           <a:prstGeom prst="rect">
             <a:avLst/>
@@ -8380,10 +8608,12 @@
           </a:bodyPr>
           <a:lstStyle/>
           <a:p>
-            <a:pPr>
+            <a:pPr marL="171450" indent="-171450">
               <a:spcAft>
                 <a:spcPts val="500"/>
               </a:spcAft>
+              <a:buFont typeface="Arial" panose="020B0604020202020204" pitchFamily="34" charset="0"/>
+              <a:buChar char="•"/>
               <a:defRPr sz="1100">
                 <a:solidFill>
                   <a:srgbClr val="F4F8FF"/>
@@ -8392,14 +8622,17 @@
               </a:defRPr>
             </a:pPr>
             <a:r>
+              <a:rPr sz="1200" dirty="0"/>
               <a:t>causal forward-only adaptation</a:t>
             </a:r>
           </a:p>
           <a:p>
-            <a:pPr>
+            <a:pPr marL="171450" indent="-171450">
               <a:spcAft>
                 <a:spcPts val="500"/>
               </a:spcAft>
+              <a:buFont typeface="Arial" panose="020B0604020202020204" pitchFamily="34" charset="0"/>
+              <a:buChar char="•"/>
               <a:defRPr sz="1100">
                 <a:solidFill>
                   <a:srgbClr val="F4F8FF"/>
@@ -8408,14 +8641,17 @@
               </a:defRPr>
             </a:pPr>
             <a:r>
+              <a:rPr sz="1200" dirty="0"/>
               <a:t>stronger uncertainty estimates</a:t>
             </a:r>
           </a:p>
           <a:p>
-            <a:pPr>
+            <a:pPr marL="171450" indent="-171450">
               <a:spcAft>
                 <a:spcPts val="500"/>
               </a:spcAft>
+              <a:buFont typeface="Arial" panose="020B0604020202020204" pitchFamily="34" charset="0"/>
+              <a:buChar char="•"/>
               <a:defRPr sz="1100">
                 <a:solidFill>
                   <a:srgbClr val="F4F8FF"/>
@@ -8424,14 +8660,17 @@
               </a:defRPr>
             </a:pPr>
             <a:r>
+              <a:rPr sz="1200" dirty="0"/>
               <a:t>lighter default model bundle</a:t>
             </a:r>
           </a:p>
           <a:p>
-            <a:pPr>
+            <a:pPr marL="171450" indent="-171450">
               <a:spcAft>
                 <a:spcPts val="500"/>
               </a:spcAft>
+              <a:buFont typeface="Arial" panose="020B0604020202020204" pitchFamily="34" charset="0"/>
+              <a:buChar char="•"/>
               <a:defRPr sz="1100">
                 <a:solidFill>
                   <a:srgbClr val="F4F8FF"/>
@@ -8440,6 +8679,7 @@
               </a:defRPr>
             </a:pPr>
             <a:r>
+              <a:rPr sz="1200" dirty="0"/>
               <a:t>downlink prioritization tied to confidence and mission value</a:t>
             </a:r>
           </a:p>
@@ -8489,7 +8729,7 @@
 </file>
 
 <file path=ppt/slides/slide7.xml><?xml version="1.0" encoding="utf-8"?>
-<p:sld xmlns:a="http://schemas.openxmlformats.org/drawingml/2006/main" xmlns:p="http://schemas.openxmlformats.org/presentationml/2006/main" xmlns:r="http://schemas.openxmlformats.org/officeDocument/2006/relationships">
+<p:sld xmlns:a="http://schemas.openxmlformats.org/drawingml/2006/main" xmlns:r="http://schemas.openxmlformats.org/officeDocument/2006/relationships" xmlns:p="http://schemas.openxmlformats.org/presentationml/2006/main">
   <p:cSld>
     <p:bg>
       <p:bgPr>
@@ -8505,7 +8745,14 @@
         <p:cNvGrpSpPr/>
         <p:nvPr/>
       </p:nvGrpSpPr>
-      <p:grpSpPr/>
+      <p:grpSpPr>
+        <a:xfrm>
+          <a:off x="0" y="0"/>
+          <a:ext cx="0" cy="0"/>
+          <a:chOff x="0" y="0"/>
+          <a:chExt cx="0" cy="0"/>
+        </a:xfrm>
+      </p:grpSpPr>
       <p:sp>
         <p:nvSpPr>
           <p:cNvPr id="2" name="Rounded Rectangle 1"/>
@@ -8569,7 +8816,7 @@
         <p:spPr>
           <a:xfrm>
             <a:off x="548640" y="749808"/>
-            <a:ext cx="7589520" cy="822960"/>
+            <a:ext cx="4380686" cy="584775"/>
           </a:xfrm>
           <a:prstGeom prst="rect">
             <a:avLst/>
@@ -8583,7 +8830,7 @@
           <a:lstStyle/>
           <a:p>
             <a:r>
-              <a:rPr sz="2500" b="1">
+              <a:rPr sz="3200" b="1">
                 <a:solidFill>
                   <a:srgbClr val="F4F8FF"/>
                 </a:solidFill>
@@ -8602,8 +8849,8 @@
         </p:nvSpPr>
         <p:spPr>
           <a:xfrm>
-            <a:off x="566928" y="1444752"/>
-            <a:ext cx="8046720" cy="438912"/>
+            <a:off x="649224" y="1180694"/>
+            <a:ext cx="7080272" cy="307777"/>
           </a:xfrm>
           <a:prstGeom prst="rect">
             <a:avLst/>
@@ -8617,7 +8864,7 @@
           <a:lstStyle/>
           <a:p>
             <a:r>
-              <a:rPr sz="1150">
+              <a:rPr sz="1400" dirty="0">
                 <a:solidFill>
                   <a:srgbClr val="B7C2D7"/>
                 </a:solidFill>
@@ -8670,6 +8917,7 @@
           <a:lstStyle/>
           <a:p>
             <a:pPr algn="ctr"/>
+            <a:endParaRPr/>
           </a:p>
         </p:txBody>
       </p:sp>
@@ -8682,7 +8930,7 @@
         <p:spPr>
           <a:xfrm>
             <a:off x="768096" y="1993392"/>
-            <a:ext cx="1362456" cy="256032"/>
+            <a:ext cx="1362456" cy="307777"/>
           </a:xfrm>
           <a:prstGeom prst="rect">
             <a:avLst/>
@@ -8701,7 +8949,7 @@
               </a:spcAft>
             </a:pPr>
             <a:r>
-              <a:rPr sz="1100" b="1">
+              <a:rPr sz="1400" b="1" dirty="0">
                 <a:solidFill>
                   <a:srgbClr val="F5B335"/>
                 </a:solidFill>
@@ -8754,6 +9002,7 @@
           <a:lstStyle/>
           <a:p>
             <a:pPr algn="ctr"/>
+            <a:endParaRPr/>
           </a:p>
         </p:txBody>
       </p:sp>
@@ -8766,7 +9015,7 @@
         <p:spPr>
           <a:xfrm>
             <a:off x="2404872" y="1993392"/>
-            <a:ext cx="1179576" cy="256032"/>
+            <a:ext cx="1179576" cy="307777"/>
           </a:xfrm>
           <a:prstGeom prst="rect">
             <a:avLst/>
@@ -8785,7 +9034,7 @@
               </a:spcAft>
             </a:pPr>
             <a:r>
-              <a:rPr sz="1100" b="1">
+              <a:rPr sz="1400" b="1">
                 <a:solidFill>
                   <a:srgbClr val="F5B335"/>
                 </a:solidFill>
@@ -8838,6 +9087,7 @@
           <a:lstStyle/>
           <a:p>
             <a:pPr algn="ctr"/>
+            <a:endParaRPr/>
           </a:p>
         </p:txBody>
       </p:sp>
@@ -8850,7 +9100,7 @@
         <p:spPr>
           <a:xfrm>
             <a:off x="3895344" y="1993392"/>
-            <a:ext cx="4014215" cy="256032"/>
+            <a:ext cx="4014215" cy="307777"/>
           </a:xfrm>
           <a:prstGeom prst="rect">
             <a:avLst/>
@@ -8869,7 +9119,7 @@
               </a:spcAft>
             </a:pPr>
             <a:r>
-              <a:rPr sz="1100" b="1">
+              <a:rPr sz="1400" b="1">
                 <a:solidFill>
                   <a:srgbClr val="F5B335"/>
                 </a:solidFill>
@@ -8922,6 +9172,7 @@
           <a:lstStyle/>
           <a:p>
             <a:pPr algn="ctr"/>
+            <a:endParaRPr/>
           </a:p>
         </p:txBody>
       </p:sp>
@@ -8934,7 +9185,7 @@
         <p:spPr>
           <a:xfrm>
             <a:off x="8375904" y="1993392"/>
-            <a:ext cx="3054096" cy="256032"/>
+            <a:ext cx="3054096" cy="307777"/>
           </a:xfrm>
           <a:prstGeom prst="rect">
             <a:avLst/>
@@ -8953,7 +9204,7 @@
               </a:spcAft>
             </a:pPr>
             <a:r>
-              <a:rPr sz="1100" b="1">
+              <a:rPr sz="1400" b="1">
                 <a:solidFill>
                   <a:srgbClr val="F5B335"/>
                 </a:solidFill>
@@ -9006,6 +9257,7 @@
           <a:lstStyle/>
           <a:p>
             <a:pPr algn="ctr"/>
+            <a:endParaRPr/>
           </a:p>
         </p:txBody>
       </p:sp>
@@ -9017,8 +9269,8 @@
         </p:nvSpPr>
         <p:spPr>
           <a:xfrm>
-            <a:off x="804672" y="2624328"/>
-            <a:ext cx="1289304" cy="749808"/>
+            <a:off x="798576" y="2890396"/>
+            <a:ext cx="1289304" cy="276999"/>
           </a:xfrm>
           <a:prstGeom prst="rect">
             <a:avLst/>
@@ -9031,13 +9283,13 @@
           </a:bodyPr>
           <a:lstStyle/>
           <a:p>
-            <a:pPr algn="l">
+            <a:pPr algn="ctr">
               <a:spcAft>
                 <a:spcPts val="300"/>
               </a:spcAft>
             </a:pPr>
             <a:r>
-              <a:rPr sz="1000" b="0">
+              <a:rPr sz="1200" b="0" dirty="0">
                 <a:solidFill>
                   <a:srgbClr val="F4F8FF"/>
                 </a:solidFill>
@@ -9090,6 +9342,7 @@
           <a:lstStyle/>
           <a:p>
             <a:pPr algn="ctr"/>
+            <a:endParaRPr/>
           </a:p>
         </p:txBody>
       </p:sp>
@@ -9101,8 +9354,8 @@
         </p:nvSpPr>
         <p:spPr>
           <a:xfrm>
-            <a:off x="2441448" y="2624328"/>
-            <a:ext cx="1106424" cy="749808"/>
+            <a:off x="2441448" y="2879020"/>
+            <a:ext cx="1106424" cy="276999"/>
           </a:xfrm>
           <a:prstGeom prst="rect">
             <a:avLst/>
@@ -9115,13 +9368,13 @@
           </a:bodyPr>
           <a:lstStyle/>
           <a:p>
-            <a:pPr algn="l">
+            <a:pPr algn="ctr">
               <a:spcAft>
                 <a:spcPts val="300"/>
               </a:spcAft>
             </a:pPr>
             <a:r>
-              <a:rPr sz="1000" b="0">
+              <a:rPr sz="1200" b="0">
                 <a:solidFill>
                   <a:srgbClr val="F4F8FF"/>
                 </a:solidFill>
@@ -9174,6 +9427,7 @@
           <a:lstStyle/>
           <a:p>
             <a:pPr algn="ctr"/>
+            <a:endParaRPr/>
           </a:p>
         </p:txBody>
       </p:sp>
@@ -9185,8 +9439,8 @@
         </p:nvSpPr>
         <p:spPr>
           <a:xfrm>
-            <a:off x="3931920" y="2624328"/>
-            <a:ext cx="3941063" cy="749808"/>
+            <a:off x="3931920" y="2798064"/>
+            <a:ext cx="3941063" cy="461665"/>
           </a:xfrm>
           <a:prstGeom prst="rect">
             <a:avLst/>
@@ -9199,13 +9453,13 @@
           </a:bodyPr>
           <a:lstStyle/>
           <a:p>
-            <a:pPr algn="l">
+            <a:pPr algn="ctr">
               <a:spcAft>
                 <a:spcPts val="300"/>
               </a:spcAft>
             </a:pPr>
             <a:r>
-              <a:rPr sz="1000" b="0">
+              <a:rPr sz="1200" b="0">
                 <a:solidFill>
                   <a:srgbClr val="F4F8FF"/>
                 </a:solidFill>
@@ -9258,6 +9512,7 @@
           <a:lstStyle/>
           <a:p>
             <a:pPr algn="ctr"/>
+            <a:endParaRPr/>
           </a:p>
         </p:txBody>
       </p:sp>
@@ -9269,8 +9524,8 @@
         </p:nvSpPr>
         <p:spPr>
           <a:xfrm>
-            <a:off x="8412480" y="2624328"/>
-            <a:ext cx="2980944" cy="749808"/>
+            <a:off x="8412480" y="2798064"/>
+            <a:ext cx="2980944" cy="461665"/>
           </a:xfrm>
           <a:prstGeom prst="rect">
             <a:avLst/>
@@ -9283,13 +9538,13 @@
           </a:bodyPr>
           <a:lstStyle/>
           <a:p>
-            <a:pPr algn="l">
+            <a:pPr algn="ctr">
               <a:spcAft>
                 <a:spcPts val="300"/>
               </a:spcAft>
             </a:pPr>
             <a:r>
-              <a:rPr sz="1000" b="0">
+              <a:rPr sz="1200" b="0">
                 <a:solidFill>
                   <a:srgbClr val="F4F8FF"/>
                 </a:solidFill>
@@ -9342,6 +9597,7 @@
           <a:lstStyle/>
           <a:p>
             <a:pPr algn="ctr"/>
+            <a:endParaRPr/>
           </a:p>
         </p:txBody>
       </p:sp>
@@ -9353,8 +9609,8 @@
         </p:nvSpPr>
         <p:spPr>
           <a:xfrm>
-            <a:off x="804672" y="3904488"/>
-            <a:ext cx="1289304" cy="749808"/>
+            <a:off x="804672" y="4170556"/>
+            <a:ext cx="1289304" cy="276999"/>
           </a:xfrm>
           <a:prstGeom prst="rect">
             <a:avLst/>
@@ -9367,13 +9623,13 @@
           </a:bodyPr>
           <a:lstStyle/>
           <a:p>
-            <a:pPr algn="l">
+            <a:pPr algn="ctr">
               <a:spcAft>
                 <a:spcPts val="300"/>
               </a:spcAft>
             </a:pPr>
             <a:r>
-              <a:rPr sz="1000" b="0">
+              <a:rPr sz="1200" b="0">
                 <a:solidFill>
                   <a:srgbClr val="F4F8FF"/>
                 </a:solidFill>
@@ -9426,6 +9682,7 @@
           <a:lstStyle/>
           <a:p>
             <a:pPr algn="ctr"/>
+            <a:endParaRPr/>
           </a:p>
         </p:txBody>
       </p:sp>
@@ -9437,8 +9694,8 @@
         </p:nvSpPr>
         <p:spPr>
           <a:xfrm>
-            <a:off x="2441448" y="3904488"/>
-            <a:ext cx="1106424" cy="749808"/>
+            <a:off x="2441448" y="4078224"/>
+            <a:ext cx="1106424" cy="461665"/>
           </a:xfrm>
           <a:prstGeom prst="rect">
             <a:avLst/>
@@ -9451,13 +9708,13 @@
           </a:bodyPr>
           <a:lstStyle/>
           <a:p>
-            <a:pPr algn="l">
+            <a:pPr algn="ctr">
               <a:spcAft>
                 <a:spcPts val="300"/>
               </a:spcAft>
             </a:pPr>
             <a:r>
-              <a:rPr sz="1000" b="0">
+              <a:rPr sz="1200" b="0" dirty="0">
                 <a:solidFill>
                   <a:srgbClr val="F4F8FF"/>
                 </a:solidFill>
@@ -9510,6 +9767,7 @@
           <a:lstStyle/>
           <a:p>
             <a:pPr algn="ctr"/>
+            <a:endParaRPr/>
           </a:p>
         </p:txBody>
       </p:sp>
@@ -9521,8 +9779,8 @@
         </p:nvSpPr>
         <p:spPr>
           <a:xfrm>
-            <a:off x="3931920" y="3904488"/>
-            <a:ext cx="3941063" cy="749808"/>
+            <a:off x="3931920" y="4078224"/>
+            <a:ext cx="3941063" cy="461665"/>
           </a:xfrm>
           <a:prstGeom prst="rect">
             <a:avLst/>
@@ -9535,13 +9793,13 @@
           </a:bodyPr>
           <a:lstStyle/>
           <a:p>
-            <a:pPr algn="l">
+            <a:pPr algn="ctr">
               <a:spcAft>
                 <a:spcPts val="300"/>
               </a:spcAft>
             </a:pPr>
             <a:r>
-              <a:rPr sz="1000" b="0">
+              <a:rPr sz="1200" b="0">
                 <a:solidFill>
                   <a:srgbClr val="F4F8FF"/>
                 </a:solidFill>
@@ -9594,6 +9852,7 @@
           <a:lstStyle/>
           <a:p>
             <a:pPr algn="ctr"/>
+            <a:endParaRPr/>
           </a:p>
         </p:txBody>
       </p:sp>
@@ -9605,8 +9864,8 @@
         </p:nvSpPr>
         <p:spPr>
           <a:xfrm>
-            <a:off x="8412480" y="3904488"/>
-            <a:ext cx="2980944" cy="749808"/>
+            <a:off x="8412480" y="4078224"/>
+            <a:ext cx="2980944" cy="461665"/>
           </a:xfrm>
           <a:prstGeom prst="rect">
             <a:avLst/>
@@ -9619,13 +9878,13 @@
           </a:bodyPr>
           <a:lstStyle/>
           <a:p>
-            <a:pPr algn="l">
+            <a:pPr algn="ctr">
               <a:spcAft>
                 <a:spcPts val="300"/>
               </a:spcAft>
             </a:pPr>
             <a:r>
-              <a:rPr sz="1000" b="0">
+              <a:rPr sz="1200" b="0">
                 <a:solidFill>
                   <a:srgbClr val="F4F8FF"/>
                 </a:solidFill>
@@ -9644,8 +9903,8 @@
         </p:nvSpPr>
         <p:spPr>
           <a:xfrm>
-            <a:off x="749808" y="5138928"/>
-            <a:ext cx="10835640" cy="749808"/>
+            <a:off x="749808" y="5138927"/>
+            <a:ext cx="10835640" cy="909721"/>
           </a:xfrm>
           <a:prstGeom prst="roundRect">
             <a:avLst/>
@@ -9678,6 +9937,7 @@
           <a:lstStyle/>
           <a:p>
             <a:pPr algn="ctr"/>
+            <a:endParaRPr/>
           </a:p>
         </p:txBody>
       </p:sp>
@@ -9689,7 +9949,7 @@
         </p:nvSpPr>
         <p:spPr>
           <a:xfrm>
-            <a:off x="914400" y="5248656"/>
+            <a:off x="914400" y="5202936"/>
             <a:ext cx="10506456" cy="320040"/>
           </a:xfrm>
           <a:prstGeom prst="rect">
@@ -9709,7 +9969,7 @@
               </a:spcAft>
             </a:pPr>
             <a:r>
-              <a:rPr sz="1300" b="1">
+              <a:rPr sz="1400" b="1" dirty="0">
                 <a:solidFill>
                   <a:srgbClr val="F5B335"/>
                 </a:solidFill>
@@ -9728,8 +9988,8 @@
         </p:nvSpPr>
         <p:spPr>
           <a:xfrm>
-            <a:off x="950976" y="5577840"/>
-            <a:ext cx="10543032" cy="201168"/>
+            <a:off x="950976" y="5532120"/>
+            <a:ext cx="10543032" cy="461665"/>
           </a:xfrm>
           <a:prstGeom prst="rect">
             <a:avLst/>
@@ -9754,7 +10014,12 @@
               </a:defRPr>
             </a:pPr>
             <a:r>
-              <a:t>HydroSat already provides a real, reproducible, container-ready baseline today, and our next step is to make that baseline more robust as an onboard water-intelligence system.</a:t>
+              <a:rPr sz="1200" dirty="0" err="1"/>
+              <a:t>HydroSat</a:t>
+            </a:r>
+            <a:r>
+              <a:rPr sz="1200" dirty="0"/>
+              <a:t> already provides a real, reproducible, container-ready baseline today, and our next step is to make that baseline more robust as an onboard water-intelligence system.</a:t>
             </a:r>
           </a:p>
         </p:txBody>

</xml_diff>